<commit_message>
Reorder script and deck for a solo 3-minute talk
Intro -> problem/solution -> Kiro -> live demo of the whole UI -> close.
Deck order now matches; backup slides moved to the end.
</commit_message>
<xml_diff>
--- a/presentation/DataMon.pptx
+++ b/presentation/DataMon.pptx
@@ -136,7 +136,7 @@
           <a:p>
             <a:r>
               <a:rPr lang="en-US" sz="1400" dirty="0"/>
-              <a:t>[0:00-0:08] Robots learn by copying recorded demonstrations. And one bad demonstration quietly teaches a robot the wrong move.</a:t>
+              <a:t>[0:00-0:10] Hi, I'm Ahmed Salah. My teammate Jesse Silva and I built DataMon for the Robotics and Hardware track.</a:t>
             </a:r>
           </a:p>
         </p:txBody>
@@ -189,7 +189,7 @@
           <a:p>
             <a:r>
               <a:rPr lang="en-US" sz="1400" dirty="0"/>
-              <a:t>[0:08-0:20] A frozen sensor. A timing glitch. A recording nobody labelled. The robot learns from all of it, and nobody notices until after an expensive training run. Garbage in, garbage out. Except here, the garbage learns to drive a robot arm.</a:t>
+              <a:t>[0:10-0:20] Robots learn by copying recorded demonstrations. But a frozen sensor, a timing glitch, or a recording nobody labelled teaches the robot the wrong thing, and nobody notices until after an expensive training run.</a:t>
             </a:r>
           </a:p>
         </p:txBody>
@@ -242,7 +242,7 @@
           <a:p>
             <a:r>
               <a:rPr lang="en-US" sz="1400" dirty="0"/>
-              <a:t>[0:20-0:30] DataMon is a quality gate for robot training data. Every recording gets a score from zero to a hundred, with the reasons, and goes one of three ways: clean, held for a human, or quarantined.</a:t>
+              <a:t>[0:20-0:30] DataMon is a quality gate. Every recording gets a score from zero to a hundred, with reasons, and is accepted, held for a human, or quarantined. (Next: Kiro slide, then switch to the live demo.)</a:t>
             </a:r>
           </a:p>
         </p:txBody>
@@ -295,7 +295,7 @@
           <a:p>
             <a:r>
               <a:rPr lang="en-US" sz="1400" dirty="0"/>
-              <a:t>(Optional explainer slide. In the video this is covered during the live demo.) Four checks: integrity, labels, an unusualness rank against known-good recordings, then routing with an audit trail. The anomaly number is a rank, not a probability.</a:t>
+              <a:t>[0:30-0:52] We built it entirely with Kiro. Kiro Crew on my laptop set up the project, ran the tests, and shipped every feature as its own pull request. Kiro Web, in the cloud, couldn't install Streamlit, so it read Streamlit's source on GitHub and used the Playwright power to screenshot the UI before shipping. Specs and steering docs kept it consistent: twenty-one pull requests, a hundred and twenty-nine passing tests. (Then switch to the live demo: see VIDEO_SCRIPT.md, 0:52-2:42.)</a:t>
             </a:r>
           </a:p>
         </p:txBody>
@@ -348,7 +348,7 @@
           <a:p>
             <a:r>
               <a:rPr lang="en-US" sz="1400" dirty="0"/>
-              <a:t>[0:30-1:35] LIVE DEMO (screen recording). 1) Sign in as judge: 'Here it is live, on real public robot data from DROID and BridgeData. The loading screen is actually scoring every recording, and telling robot jokes while it works.' 2) Ingest gate, stream the reject episode: 'I'll replay a recording frame by frame, as if it's coming off a robot right now... and it's rejected. You see the verdict, and you hear it.' 3) Review queue: 'When the gate isn't sure, it asks. I can promote this one, reject it, or send it back to be recorded again. Every decision lands in an audit trail that's never overwritten.' 4) Dataset quality: 'The report card for the whole dataset: a score, a verdict and the reasons for every recording.' 5) Label / coverage: 'And here, recordings with missing or nonsense task labels. The robot was never told what it was doing.'</a:t>
+              <a:t>[2:42-2:55] It reads the open LeRobot format, so it works with any dataset published that way. Good data in, bad data out. That's DataMon. Thanks for watching.</a:t>
             </a:r>
           </a:p>
         </p:txBody>
@@ -401,7 +401,7 @@
           <a:p>
             <a:r>
               <a:rPr lang="en-US" sz="1400" dirty="0"/>
-              <a:t>[1:35-1:55] (Show ~5 s of tour step 1 first.) We built it so nobody's left out: a narrated tour with captions and a pointing arrow, a help assistant that only answers from our own docs, and reduced-motion support throughout.</a:t>
+              <a:t>(BACKUP SLIDE, not in the video.) Four checks: integrity, labels, an unusualness rank against known-good recordings, then routing with an audit trail. The anomaly number is a rank, not a probability.</a:t>
             </a:r>
           </a:p>
         </p:txBody>
@@ -454,7 +454,7 @@
           <a:p>
             <a:r>
               <a:rPr lang="en-US" sz="1400" dirty="0"/>
-              <a:t>[1:55-2:30] We built all of it with Kiro, using two of its tools. Kiro Crew on a laptop set up Python, ran the app and tests, and shipped each feature as its own pull request. Kiro Web worked in a cloud sandbox that couldn't install Streamlit, so it read Streamlit's source on GitHub, let CI run the tests, and used the Playwright power to screenshot the interface before shipping. Specs defined our core features, and two steering docs kept every session honest and tested. Twenty-one pull requests, a hundred and twenty-nine passing tests.</a:t>
+              <a:t>(BACKUP SLIDE, not in the video.) Narrated tour with captions and a pointing arrow, a grounded help assistant, a sound plus a colour-coded verdict on rejections, and reduced-motion support.</a:t>
             </a:r>
           </a:p>
         </p:txBody>
@@ -507,7 +507,7 @@
           <a:p>
             <a:r>
               <a:rPr lang="en-US" sz="1400" dirty="0"/>
-              <a:t>[2:30-2:45] DataMon reads the open LeRobot format, so it works on any dataset published that way, and live robots can stream straight in. Labs, data-collection teams and dataset publishers catch bad data while it's still cheap to fix.</a:t>
+              <a:t>(BACKUP SLIDE, not in the video.) Labs, data-collection teams and dataset publishers. Reads any LeRobot dataset, streams from live robots, per-robot profiles and per-task baselines.</a:t>
             </a:r>
           </a:p>
         </p:txBody>
@@ -560,7 +560,7 @@
           <a:p>
             <a:r>
               <a:rPr lang="en-US" sz="1400" dirty="0"/>
-              <a:t>[2:45-2:52] Good data in. Bad data out. That's DataMon.</a:t>
+              <a:t>(BACKUP SLIDE, not in the video.) Live site and judge sign-in, for a live presentation or questions.</a:t>
             </a:r>
           </a:p>
         </p:txBody>
@@ -2659,7 +2659,7 @@
                 <a:latin typeface="Montserrat"/>
                 <a:cs typeface="Montserrat"/>
               </a:rPr>
-              <a:t>HOW IT WORKS</a:t>
+              <a:t>IMPLEMENTATION</a:t>
             </a:r>
             <a:endParaRPr lang="en-US" sz="1300" dirty="0"/>
           </a:p>
@@ -2701,7 +2701,7 @@
                 <a:latin typeface="Montserrat"/>
                 <a:cs typeface="Montserrat"/>
               </a:rPr>
-              <a:t>Four checks, in plain terms</a:t>
+              <a:t>How we used Kiro</a:t>
             </a:r>
             <a:endParaRPr lang="en-US" sz="3400" dirty="0"/>
           </a:p>
@@ -2715,8 +2715,8 @@
         </p:nvSpPr>
         <p:spPr>
           <a:xfrm>
-            <a:off x="685800" y="2011680"/>
-            <a:ext cx="2560320" cy="2148840"/>
+            <a:off x="685800" y="1783080"/>
+            <a:ext cx="5257800" cy="2011680"/>
           </a:xfrm>
           <a:prstGeom prst="roundRect">
             <a:avLst>
@@ -2742,127 +2742,148 @@
       </p:sp>
       <p:sp>
         <p:nvSpPr>
-          <p:cNvPr id="6" name="Shape 6"/>
-          <p:cNvSpPr/>
-          <p:nvPr/>
-        </p:nvSpPr>
-        <p:spPr>
-          <a:xfrm>
-            <a:off x="685800" y="2176272"/>
-            <a:ext cx="64008" cy="1819656"/>
-          </a:xfrm>
-          <a:prstGeom prst="rect">
-            <a:avLst/>
-          </a:prstGeom>
-          <a:solidFill>
-            <a:srgbClr val="2DD4BF"/>
-          </a:solidFill>
-          <a:ln>
-            <a:noFill/>
-          </a:ln>
-        </p:spPr>
-        <p:txBody>
-          <a:bodyPr/>
-          <a:lstStyle/>
-          <a:p>
-            <a:endParaRPr lang="en-US"/>
-          </a:p>
-        </p:txBody>
-      </p:sp>
-      <p:sp>
-        <p:nvSpPr>
-          <p:cNvPr id="7" name="Text 7"/>
-          <p:cNvSpPr txBox="1"/>
-          <p:nvPr/>
-        </p:nvSpPr>
-        <p:spPr>
-          <a:xfrm>
-            <a:off x="914400" y="2148840"/>
-            <a:ext cx="2194560" cy="457200"/>
-          </a:xfrm>
-          <a:prstGeom prst="rect">
-            <a:avLst/>
-          </a:prstGeom>
-          <a:noFill/>
-          <a:ln>
-            <a:noFill/>
-          </a:ln>
-        </p:spPr>
-        <p:txBody>
-          <a:bodyPr wrap="square" lIns="73152" tIns="73152" rIns="73152" bIns="73152" anchor="t">
-            <a:noAutofit/>
-          </a:bodyPr>
-          <a:lstStyle/>
-          <a:p>
-            <a:pPr algn="l">
-              <a:buNone/>
-            </a:pPr>
-            <a:r>
-              <a:rPr lang="en-US" sz="1700" b="1" i="0" dirty="0">
+          <p:cNvPr id="6" name="Text 6"/>
+          <p:cNvSpPr txBox="1"/>
+          <p:nvPr/>
+        </p:nvSpPr>
+        <p:spPr>
+          <a:xfrm>
+            <a:off x="914400" y="1874520"/>
+            <a:ext cx="4846320" cy="457200"/>
+          </a:xfrm>
+          <a:prstGeom prst="rect">
+            <a:avLst/>
+          </a:prstGeom>
+          <a:noFill/>
+          <a:ln>
+            <a:noFill/>
+          </a:ln>
+        </p:spPr>
+        <p:txBody>
+          <a:bodyPr wrap="square" lIns="73152" tIns="73152" rIns="73152" bIns="73152" anchor="t">
+            <a:noAutofit/>
+          </a:bodyPr>
+          <a:lstStyle/>
+          <a:p>
+            <a:pPr algn="l">
+              <a:buNone/>
+            </a:pPr>
+            <a:r>
+              <a:rPr lang="en-US" sz="1800" b="1" i="0" dirty="0">
                 <a:solidFill>
                   <a:srgbClr val="2DD4BF"/>
                 </a:solidFill>
                 <a:latin typeface="Montserrat"/>
                 <a:cs typeface="Montserrat"/>
               </a:rPr>
-              <a:t>1  Integrity</a:t>
-            </a:r>
-            <a:endParaRPr lang="en-US" sz="1700" dirty="0"/>
-          </a:p>
-        </p:txBody>
-      </p:sp>
-      <p:sp>
-        <p:nvSpPr>
-          <p:cNvPr id="8" name="Text 8"/>
-          <p:cNvSpPr txBox="1"/>
-          <p:nvPr/>
-        </p:nvSpPr>
-        <p:spPr>
-          <a:xfrm>
-            <a:off x="914400" y="2578608"/>
-            <a:ext cx="2194560" cy="1463040"/>
-          </a:xfrm>
-          <a:prstGeom prst="rect">
-            <a:avLst/>
-          </a:prstGeom>
-          <a:noFill/>
-          <a:ln>
-            <a:noFill/>
-          </a:ln>
-        </p:spPr>
-        <p:txBody>
-          <a:bodyPr wrap="square" lIns="73152" tIns="73152" rIns="73152" bIns="73152" anchor="t">
-            <a:noAutofit/>
-          </a:bodyPr>
-          <a:lstStyle/>
-          <a:p>
-            <a:pPr algn="l">
-              <a:buNone/>
-            </a:pPr>
-            <a:r>
-              <a:rPr lang="en-US" sz="1300" b="0" i="0" dirty="0">
+              <a:t>Kiro Crew  ·  local laptop</a:t>
+            </a:r>
+            <a:endParaRPr lang="en-US" sz="1800" dirty="0"/>
+          </a:p>
+        </p:txBody>
+      </p:sp>
+      <p:sp>
+        <p:nvSpPr>
+          <p:cNvPr id="7" name="Text 7"/>
+          <p:cNvSpPr txBox="1"/>
+          <p:nvPr/>
+        </p:nvSpPr>
+        <p:spPr>
+          <a:xfrm>
+            <a:off x="914400" y="2331720"/>
+            <a:ext cx="4846320" cy="1737360"/>
+          </a:xfrm>
+          <a:prstGeom prst="rect">
+            <a:avLst/>
+          </a:prstGeom>
+          <a:noFill/>
+          <a:ln>
+            <a:noFill/>
+          </a:ln>
+        </p:spPr>
+        <p:txBody>
+          <a:bodyPr wrap="square" lIns="73152" tIns="73152" rIns="73152" bIns="73152" anchor="t">
+            <a:noAutofit/>
+          </a:bodyPr>
+          <a:lstStyle/>
+          <a:p>
+            <a:pPr algn="l" marL="285750" indent="-285750">
+              <a:buClr>
+                <a:srgbClr val="2DD4BF"/>
+              </a:buClr>
+              <a:buFont typeface="Arial"/>
+              <a:buChar char="•"/>
+            </a:pPr>
+            <a:r>
+              <a:rPr lang="en-US" sz="1350" b="0" i="0" dirty="0">
                 <a:solidFill>
                   <a:srgbClr val="E6EDF3"/>
                 </a:solidFill>
                 <a:latin typeface="Open Sans"/>
                 <a:cs typeface="Open Sans"/>
               </a:rPr>
-              <a:t>Is the timing steady? Any dropped frames, frozen channels or values out of range?</a:t>
-            </a:r>
-            <a:endParaRPr lang="en-US" sz="1300" dirty="0"/>
-          </a:p>
-        </p:txBody>
-      </p:sp>
-      <p:sp>
-        <p:nvSpPr>
-          <p:cNvPr id="9" name="Shape 9"/>
+              <a:t>Set up Python and the virtual environment</a:t>
+            </a:r>
+            <a:endParaRPr lang="en-US" sz="1350" dirty="0"/>
+          </a:p>
+          <a:p>
+            <a:pPr algn="l" marL="285750" indent="-285750">
+              <a:spcBef>
+                <a:spcPts val="400"/>
+              </a:spcBef>
+              <a:buClr>
+                <a:srgbClr val="2DD4BF"/>
+              </a:buClr>
+              <a:buFont typeface="Arial"/>
+              <a:buChar char="•"/>
+            </a:pPr>
+            <a:r>
+              <a:rPr lang="en-US" sz="1350" b="0" i="0" dirty="0">
+                <a:solidFill>
+                  <a:srgbClr val="E6EDF3"/>
+                </a:solidFill>
+                <a:latin typeface="Open Sans"/>
+                <a:cs typeface="Open Sans"/>
+              </a:rPr>
+              <a:t>Ran the app and the tests on the real machine</a:t>
+            </a:r>
+            <a:endParaRPr lang="en-US" sz="1350" dirty="0"/>
+          </a:p>
+          <a:p>
+            <a:pPr algn="l" marL="285750" indent="-285750">
+              <a:spcBef>
+                <a:spcPts val="400"/>
+              </a:spcBef>
+              <a:buClr>
+                <a:srgbClr val="2DD4BF"/>
+              </a:buClr>
+              <a:buFont typeface="Arial"/>
+              <a:buChar char="•"/>
+            </a:pPr>
+            <a:r>
+              <a:rPr lang="en-US" sz="1350" b="0" i="0" dirty="0">
+                <a:solidFill>
+                  <a:srgbClr val="E6EDF3"/>
+                </a:solidFill>
+                <a:latin typeface="Open Sans"/>
+                <a:cs typeface="Open Sans"/>
+              </a:rPr>
+              <a:t>Shipped every feature as its own branch, pull request and merge</a:t>
+            </a:r>
+            <a:endParaRPr lang="en-US" sz="1350" dirty="0"/>
+          </a:p>
+        </p:txBody>
+      </p:sp>
+      <p:sp>
+        <p:nvSpPr>
+          <p:cNvPr id="8" name="Shape 8"/>
           <p:cNvSpPr/>
           <p:nvPr/>
         </p:nvSpPr>
         <p:spPr>
           <a:xfrm>
-            <a:off x="3429000" y="2011680"/>
-            <a:ext cx="2560320" cy="2148840"/>
+            <a:off x="6263640" y="1783080"/>
+            <a:ext cx="5257800" cy="2011680"/>
           </a:xfrm>
           <a:prstGeom prst="roundRect">
             <a:avLst>
@@ -2888,14 +2909,526 @@
       </p:sp>
       <p:sp>
         <p:nvSpPr>
-          <p:cNvPr id="10" name="Shape 10"/>
+          <p:cNvPr id="9" name="Text 9"/>
+          <p:cNvSpPr txBox="1"/>
+          <p:nvPr/>
+        </p:nvSpPr>
+        <p:spPr>
+          <a:xfrm>
+            <a:off x="6492240" y="1874520"/>
+            <a:ext cx="4846320" cy="457200"/>
+          </a:xfrm>
+          <a:prstGeom prst="rect">
+            <a:avLst/>
+          </a:prstGeom>
+          <a:noFill/>
+          <a:ln>
+            <a:noFill/>
+          </a:ln>
+        </p:spPr>
+        <p:txBody>
+          <a:bodyPr wrap="square" lIns="73152" tIns="73152" rIns="73152" bIns="73152" anchor="t">
+            <a:noAutofit/>
+          </a:bodyPr>
+          <a:lstStyle/>
+          <a:p>
+            <a:pPr algn="l">
+              <a:buNone/>
+            </a:pPr>
+            <a:r>
+              <a:rPr lang="en-US" sz="1800" b="1" i="0" dirty="0">
+                <a:solidFill>
+                  <a:srgbClr val="2DD4BF"/>
+                </a:solidFill>
+                <a:latin typeface="Montserrat"/>
+                <a:cs typeface="Montserrat"/>
+              </a:rPr>
+              <a:t>Kiro Web  ·  cloud sandbox</a:t>
+            </a:r>
+            <a:endParaRPr lang="en-US" sz="1800" dirty="0"/>
+          </a:p>
+        </p:txBody>
+      </p:sp>
+      <p:sp>
+        <p:nvSpPr>
+          <p:cNvPr id="10" name="Text 10"/>
+          <p:cNvSpPr txBox="1"/>
+          <p:nvPr/>
+        </p:nvSpPr>
+        <p:spPr>
+          <a:xfrm>
+            <a:off x="6492240" y="2331720"/>
+            <a:ext cx="4846320" cy="1737360"/>
+          </a:xfrm>
+          <a:prstGeom prst="rect">
+            <a:avLst/>
+          </a:prstGeom>
+          <a:noFill/>
+          <a:ln>
+            <a:noFill/>
+          </a:ln>
+        </p:spPr>
+        <p:txBody>
+          <a:bodyPr wrap="square" lIns="73152" tIns="73152" rIns="73152" bIns="73152" anchor="t">
+            <a:noAutofit/>
+          </a:bodyPr>
+          <a:lstStyle/>
+          <a:p>
+            <a:pPr algn="l" marL="285750" indent="-285750">
+              <a:buClr>
+                <a:srgbClr val="2DD4BF"/>
+              </a:buClr>
+              <a:buFont typeface="Arial"/>
+              <a:buChar char="•"/>
+            </a:pPr>
+            <a:r>
+              <a:rPr lang="en-US" sz="1350" b="0" i="0" dirty="0">
+                <a:solidFill>
+                  <a:srgbClr val="E6EDF3"/>
+                </a:solidFill>
+                <a:latin typeface="Open Sans"/>
+                <a:cs typeface="Open Sans"/>
+              </a:rPr>
+              <a:t>No internet to install Streamlit, so it read the library's source on GitHub</a:t>
+            </a:r>
+            <a:endParaRPr lang="en-US" sz="1350" dirty="0"/>
+          </a:p>
+          <a:p>
+            <a:pPr algn="l" marL="285750" indent="-285750">
+              <a:spcBef>
+                <a:spcPts val="400"/>
+              </a:spcBef>
+              <a:buClr>
+                <a:srgbClr val="2DD4BF"/>
+              </a:buClr>
+              <a:buFont typeface="Arial"/>
+              <a:buChar char="•"/>
+            </a:pPr>
+            <a:r>
+              <a:rPr lang="en-US" sz="1350" b="0" i="0" dirty="0">
+                <a:solidFill>
+                  <a:srgbClr val="E6EDF3"/>
+                </a:solidFill>
+                <a:latin typeface="Open Sans"/>
+                <a:cs typeface="Open Sans"/>
+              </a:rPr>
+              <a:t>Playwright power (MCP) rendered and screenshotted the UI</a:t>
+            </a:r>
+            <a:endParaRPr lang="en-US" sz="1350" dirty="0"/>
+          </a:p>
+          <a:p>
+            <a:pPr algn="l" marL="285750" indent="-285750">
+              <a:spcBef>
+                <a:spcPts val="400"/>
+              </a:spcBef>
+              <a:buClr>
+                <a:srgbClr val="2DD4BF"/>
+              </a:buClr>
+              <a:buFont typeface="Arial"/>
+              <a:buChar char="•"/>
+            </a:pPr>
+            <a:r>
+              <a:rPr lang="en-US" sz="1350" b="0" i="0" dirty="0">
+                <a:solidFill>
+                  <a:srgbClr val="E6EDF3"/>
+                </a:solidFill>
+                <a:latin typeface="Open Sans"/>
+                <a:cs typeface="Open Sans"/>
+              </a:rPr>
+              <a:t>GitHub CI ran the full test suite on every pull request</a:t>
+            </a:r>
+            <a:endParaRPr lang="en-US" sz="1350" dirty="0"/>
+          </a:p>
+        </p:txBody>
+      </p:sp>
+      <p:sp>
+        <p:nvSpPr>
+          <p:cNvPr id="11" name="Text 11"/>
+          <p:cNvSpPr txBox="1"/>
+          <p:nvPr/>
+        </p:nvSpPr>
+        <p:spPr>
+          <a:xfrm>
+            <a:off x="685800" y="4160520"/>
+            <a:ext cx="2560320" cy="548640"/>
+          </a:xfrm>
+          <a:prstGeom prst="rect">
+            <a:avLst/>
+          </a:prstGeom>
+          <a:noFill/>
+          <a:ln>
+            <a:noFill/>
+          </a:ln>
+        </p:spPr>
+        <p:txBody>
+          <a:bodyPr wrap="square" lIns="73152" tIns="73152" rIns="73152" bIns="73152" anchor="t">
+            <a:noAutofit/>
+          </a:bodyPr>
+          <a:lstStyle/>
+          <a:p>
+            <a:pPr algn="l">
+              <a:buNone/>
+            </a:pPr>
+            <a:r>
+              <a:rPr lang="en-US" sz="2800" b="1" i="0" dirty="0">
+                <a:solidFill>
+                  <a:srgbClr val="2DD4BF"/>
+                </a:solidFill>
+                <a:latin typeface="Montserrat"/>
+                <a:cs typeface="Montserrat"/>
+              </a:rPr>
+              <a:t>Specs</a:t>
+            </a:r>
+            <a:endParaRPr lang="en-US" sz="2800" dirty="0"/>
+          </a:p>
+        </p:txBody>
+      </p:sp>
+      <p:sp>
+        <p:nvSpPr>
+          <p:cNvPr id="12" name="Text 12"/>
+          <p:cNvSpPr txBox="1"/>
+          <p:nvPr/>
+        </p:nvSpPr>
+        <p:spPr>
+          <a:xfrm>
+            <a:off x="685800" y="4709160"/>
+            <a:ext cx="2560320" cy="731520"/>
+          </a:xfrm>
+          <a:prstGeom prst="rect">
+            <a:avLst/>
+          </a:prstGeom>
+          <a:noFill/>
+          <a:ln>
+            <a:noFill/>
+          </a:ln>
+        </p:spPr>
+        <p:txBody>
+          <a:bodyPr wrap="square" lIns="73152" tIns="73152" rIns="73152" bIns="73152" anchor="t">
+            <a:noAutofit/>
+          </a:bodyPr>
+          <a:lstStyle/>
+          <a:p>
+            <a:pPr algn="l">
+              <a:buNone/>
+            </a:pPr>
+            <a:r>
+              <a:rPr lang="en-US" sz="1300" b="0" i="0" dirty="0">
+                <a:solidFill>
+                  <a:srgbClr val="E6EDF3"/>
+                </a:solidFill>
+                <a:latin typeface="Open Sans"/>
+                <a:cs typeface="Open Sans"/>
+              </a:rPr>
+              <a:t>requirements, design and tasks for core features</a:t>
+            </a:r>
+            <a:endParaRPr lang="en-US" sz="1300" dirty="0"/>
+          </a:p>
+        </p:txBody>
+      </p:sp>
+      <p:sp>
+        <p:nvSpPr>
+          <p:cNvPr id="13" name="Text 13"/>
+          <p:cNvSpPr txBox="1"/>
+          <p:nvPr/>
+        </p:nvSpPr>
+        <p:spPr>
+          <a:xfrm>
+            <a:off x="3429000" y="4160520"/>
+            <a:ext cx="2560320" cy="548640"/>
+          </a:xfrm>
+          <a:prstGeom prst="rect">
+            <a:avLst/>
+          </a:prstGeom>
+          <a:noFill/>
+          <a:ln>
+            <a:noFill/>
+          </a:ln>
+        </p:spPr>
+        <p:txBody>
+          <a:bodyPr wrap="square" lIns="73152" tIns="73152" rIns="73152" bIns="73152" anchor="t">
+            <a:noAutofit/>
+          </a:bodyPr>
+          <a:lstStyle/>
+          <a:p>
+            <a:pPr algn="l">
+              <a:buNone/>
+            </a:pPr>
+            <a:r>
+              <a:rPr lang="en-US" sz="2800" b="1" i="0" dirty="0">
+                <a:solidFill>
+                  <a:srgbClr val="2DD4BF"/>
+                </a:solidFill>
+                <a:latin typeface="Montserrat"/>
+                <a:cs typeface="Montserrat"/>
+              </a:rPr>
+              <a:t>Steering</a:t>
+            </a:r>
+            <a:endParaRPr lang="en-US" sz="2800" dirty="0"/>
+          </a:p>
+        </p:txBody>
+      </p:sp>
+      <p:sp>
+        <p:nvSpPr>
+          <p:cNvPr id="14" name="Text 14"/>
+          <p:cNvSpPr txBox="1"/>
+          <p:nvPr/>
+        </p:nvSpPr>
+        <p:spPr>
+          <a:xfrm>
+            <a:off x="3429000" y="4709160"/>
+            <a:ext cx="2560320" cy="731520"/>
+          </a:xfrm>
+          <a:prstGeom prst="rect">
+            <a:avLst/>
+          </a:prstGeom>
+          <a:noFill/>
+          <a:ln>
+            <a:noFill/>
+          </a:ln>
+        </p:spPr>
+        <p:txBody>
+          <a:bodyPr wrap="square" lIns="73152" tIns="73152" rIns="73152" bIns="73152" anchor="t">
+            <a:noAutofit/>
+          </a:bodyPr>
+          <a:lstStyle/>
+          <a:p>
+            <a:pPr algn="l">
+              <a:buNone/>
+            </a:pPr>
+            <a:r>
+              <a:rPr lang="en-US" sz="1300" b="0" i="0" dirty="0">
+                <a:solidFill>
+                  <a:srgbClr val="E6EDF3"/>
+                </a:solidFill>
+                <a:latin typeface="Open Sans"/>
+                <a:cs typeface="Open Sans"/>
+              </a:rPr>
+              <a:t>2 docs: test before merge, no overclaiming</a:t>
+            </a:r>
+            <a:endParaRPr lang="en-US" sz="1300" dirty="0"/>
+          </a:p>
+        </p:txBody>
+      </p:sp>
+      <p:sp>
+        <p:nvSpPr>
+          <p:cNvPr id="15" name="Text 15"/>
+          <p:cNvSpPr txBox="1"/>
+          <p:nvPr/>
+        </p:nvSpPr>
+        <p:spPr>
+          <a:xfrm>
+            <a:off x="6172200" y="4160520"/>
+            <a:ext cx="2560320" cy="548640"/>
+          </a:xfrm>
+          <a:prstGeom prst="rect">
+            <a:avLst/>
+          </a:prstGeom>
+          <a:noFill/>
+          <a:ln>
+            <a:noFill/>
+          </a:ln>
+        </p:spPr>
+        <p:txBody>
+          <a:bodyPr wrap="square" lIns="73152" tIns="73152" rIns="73152" bIns="73152" anchor="t">
+            <a:noAutofit/>
+          </a:bodyPr>
+          <a:lstStyle/>
+          <a:p>
+            <a:pPr algn="l">
+              <a:buNone/>
+            </a:pPr>
+            <a:r>
+              <a:rPr lang="en-US" sz="2800" b="1" i="0" dirty="0">
+                <a:solidFill>
+                  <a:srgbClr val="2DD4BF"/>
+                </a:solidFill>
+                <a:latin typeface="Montserrat"/>
+                <a:cs typeface="Montserrat"/>
+              </a:rPr>
+              <a:t>21</a:t>
+            </a:r>
+            <a:endParaRPr lang="en-US" sz="2800" dirty="0"/>
+          </a:p>
+        </p:txBody>
+      </p:sp>
+      <p:sp>
+        <p:nvSpPr>
+          <p:cNvPr id="16" name="Text 16"/>
+          <p:cNvSpPr txBox="1"/>
+          <p:nvPr/>
+        </p:nvSpPr>
+        <p:spPr>
+          <a:xfrm>
+            <a:off x="6172200" y="4709160"/>
+            <a:ext cx="2560320" cy="731520"/>
+          </a:xfrm>
+          <a:prstGeom prst="rect">
+            <a:avLst/>
+          </a:prstGeom>
+          <a:noFill/>
+          <a:ln>
+            <a:noFill/>
+          </a:ln>
+        </p:spPr>
+        <p:txBody>
+          <a:bodyPr wrap="square" lIns="73152" tIns="73152" rIns="73152" bIns="73152" anchor="t">
+            <a:noAutofit/>
+          </a:bodyPr>
+          <a:lstStyle/>
+          <a:p>
+            <a:pPr algn="l">
+              <a:buNone/>
+            </a:pPr>
+            <a:r>
+              <a:rPr lang="en-US" sz="1300" b="0" i="0" dirty="0">
+                <a:solidFill>
+                  <a:srgbClr val="E6EDF3"/>
+                </a:solidFill>
+                <a:latin typeface="Open Sans"/>
+                <a:cs typeface="Open Sans"/>
+              </a:rPr>
+              <a:t>merged pull requests</a:t>
+            </a:r>
+            <a:endParaRPr lang="en-US" sz="1300" dirty="0"/>
+          </a:p>
+        </p:txBody>
+      </p:sp>
+      <p:sp>
+        <p:nvSpPr>
+          <p:cNvPr id="17" name="Text 17"/>
+          <p:cNvSpPr txBox="1"/>
+          <p:nvPr/>
+        </p:nvSpPr>
+        <p:spPr>
+          <a:xfrm>
+            <a:off x="8915400" y="4160520"/>
+            <a:ext cx="2560320" cy="548640"/>
+          </a:xfrm>
+          <a:prstGeom prst="rect">
+            <a:avLst/>
+          </a:prstGeom>
+          <a:noFill/>
+          <a:ln>
+            <a:noFill/>
+          </a:ln>
+        </p:spPr>
+        <p:txBody>
+          <a:bodyPr wrap="square" lIns="73152" tIns="73152" rIns="73152" bIns="73152" anchor="t">
+            <a:noAutofit/>
+          </a:bodyPr>
+          <a:lstStyle/>
+          <a:p>
+            <a:pPr algn="l">
+              <a:buNone/>
+            </a:pPr>
+            <a:r>
+              <a:rPr lang="en-US" sz="2800" b="1" i="0" dirty="0">
+                <a:solidFill>
+                  <a:srgbClr val="2DD4BF"/>
+                </a:solidFill>
+                <a:latin typeface="Montserrat"/>
+                <a:cs typeface="Montserrat"/>
+              </a:rPr>
+              <a:t>129</a:t>
+            </a:r>
+            <a:endParaRPr lang="en-US" sz="2800" dirty="0"/>
+          </a:p>
+        </p:txBody>
+      </p:sp>
+      <p:sp>
+        <p:nvSpPr>
+          <p:cNvPr id="18" name="Text 18"/>
+          <p:cNvSpPr txBox="1"/>
+          <p:nvPr/>
+        </p:nvSpPr>
+        <p:spPr>
+          <a:xfrm>
+            <a:off x="8915400" y="4709160"/>
+            <a:ext cx="2560320" cy="731520"/>
+          </a:xfrm>
+          <a:prstGeom prst="rect">
+            <a:avLst/>
+          </a:prstGeom>
+          <a:noFill/>
+          <a:ln>
+            <a:noFill/>
+          </a:ln>
+        </p:spPr>
+        <p:txBody>
+          <a:bodyPr wrap="square" lIns="73152" tIns="73152" rIns="73152" bIns="73152" anchor="t">
+            <a:noAutofit/>
+          </a:bodyPr>
+          <a:lstStyle/>
+          <a:p>
+            <a:pPr algn="l">
+              <a:buNone/>
+            </a:pPr>
+            <a:r>
+              <a:rPr lang="en-US" sz="1300" b="0" i="0" dirty="0">
+                <a:solidFill>
+                  <a:srgbClr val="E6EDF3"/>
+                </a:solidFill>
+                <a:latin typeface="Open Sans"/>
+                <a:cs typeface="Open Sans"/>
+              </a:rPr>
+              <a:t>tests passing on Python 3.9 &amp; 3.13</a:t>
+            </a:r>
+            <a:endParaRPr lang="en-US" sz="1300" dirty="0"/>
+          </a:p>
+        </p:txBody>
+      </p:sp>
+      <p:sp>
+        <p:nvSpPr>
+          <p:cNvPr id="19" name="Text 19"/>
+          <p:cNvSpPr txBox="1"/>
+          <p:nvPr/>
+        </p:nvSpPr>
+        <p:spPr>
+          <a:xfrm>
+            <a:off x="685800" y="5532120"/>
+            <a:ext cx="10789920" cy="457200"/>
+          </a:xfrm>
+          <a:prstGeom prst="rect">
+            <a:avLst/>
+          </a:prstGeom>
+          <a:noFill/>
+          <a:ln>
+            <a:noFill/>
+          </a:ln>
+        </p:spPr>
+        <p:txBody>
+          <a:bodyPr wrap="square" lIns="73152" tIns="73152" rIns="73152" bIns="73152" anchor="t">
+            <a:noAutofit/>
+          </a:bodyPr>
+          <a:lstStyle/>
+          <a:p>
+            <a:pPr algn="l">
+              <a:buNone/>
+            </a:pPr>
+            <a:r>
+              <a:rPr lang="en-US" sz="1250" b="0" i="1" dirty="0">
+                <a:solidFill>
+                  <a:srgbClr val="9FB3C8"/>
+                </a:solidFill>
+                <a:latin typeface="Open Sans"/>
+                <a:cs typeface="Open Sans"/>
+              </a:rPr>
+              <a:t>Full write-up and specs: the /.kiro folder in our repo.</a:t>
+            </a:r>
+            <a:endParaRPr lang="en-US" sz="1250" dirty="0"/>
+          </a:p>
+        </p:txBody>
+      </p:sp>
+      <p:sp>
+        <p:nvSpPr>
+          <p:cNvPr id="20" name="Shape 20"/>
           <p:cNvSpPr/>
           <p:nvPr/>
         </p:nvSpPr>
         <p:spPr>
           <a:xfrm>
-            <a:off x="3429000" y="2176272"/>
-            <a:ext cx="64008" cy="1819656"/>
+            <a:off x="685800" y="6419088"/>
+            <a:ext cx="502920" cy="45720"/>
           </a:xfrm>
           <a:prstGeom prst="rect">
             <a:avLst/>
@@ -2917,497 +3450,40 @@
       </p:sp>
       <p:sp>
         <p:nvSpPr>
-          <p:cNvPr id="11" name="Text 11"/>
-          <p:cNvSpPr txBox="1"/>
-          <p:nvPr/>
-        </p:nvSpPr>
-        <p:spPr>
-          <a:xfrm>
-            <a:off x="3657600" y="2148840"/>
-            <a:ext cx="2194560" cy="457200"/>
-          </a:xfrm>
-          <a:prstGeom prst="rect">
-            <a:avLst/>
-          </a:prstGeom>
-          <a:noFill/>
-          <a:ln>
-            <a:noFill/>
-          </a:ln>
-        </p:spPr>
-        <p:txBody>
-          <a:bodyPr wrap="square" lIns="73152" tIns="73152" rIns="73152" bIns="73152" anchor="t">
-            <a:noAutofit/>
-          </a:bodyPr>
-          <a:lstStyle/>
-          <a:p>
-            <a:pPr algn="l">
-              <a:buNone/>
-            </a:pPr>
-            <a:r>
-              <a:rPr lang="en-US" sz="1700" b="1" i="0" dirty="0">
-                <a:solidFill>
-                  <a:srgbClr val="2DD4BF"/>
-                </a:solidFill>
-                <a:latin typeface="Montserrat"/>
-                <a:cs typeface="Montserrat"/>
-              </a:rPr>
-              <a:t>2  Labels</a:t>
-            </a:r>
-            <a:endParaRPr lang="en-US" sz="1700" dirty="0"/>
-          </a:p>
-        </p:txBody>
-      </p:sp>
-      <p:sp>
-        <p:nvSpPr>
-          <p:cNvPr id="12" name="Text 12"/>
-          <p:cNvSpPr txBox="1"/>
-          <p:nvPr/>
-        </p:nvSpPr>
-        <p:spPr>
-          <a:xfrm>
-            <a:off x="3657600" y="2578608"/>
-            <a:ext cx="2194560" cy="1463040"/>
-          </a:xfrm>
-          <a:prstGeom prst="rect">
-            <a:avLst/>
-          </a:prstGeom>
-          <a:noFill/>
-          <a:ln>
-            <a:noFill/>
-          </a:ln>
-        </p:spPr>
-        <p:txBody>
-          <a:bodyPr wrap="square" lIns="73152" tIns="73152" rIns="73152" bIns="73152" anchor="t">
-            <a:noAutofit/>
-          </a:bodyPr>
-          <a:lstStyle/>
-          <a:p>
-            <a:pPr algn="l">
-              <a:buNone/>
-            </a:pPr>
-            <a:r>
-              <a:rPr lang="en-US" sz="1300" b="0" i="0" dirty="0">
-                <a:solidFill>
-                  <a:srgbClr val="E6EDF3"/>
+          <p:cNvPr id="21" name="Text 21"/>
+          <p:cNvSpPr txBox="1"/>
+          <p:nvPr/>
+        </p:nvSpPr>
+        <p:spPr>
+          <a:xfrm>
+            <a:off x="1280160" y="6272784"/>
+            <a:ext cx="5486400" cy="320040"/>
+          </a:xfrm>
+          <a:prstGeom prst="rect">
+            <a:avLst/>
+          </a:prstGeom>
+          <a:noFill/>
+          <a:ln>
+            <a:noFill/>
+          </a:ln>
+        </p:spPr>
+        <p:txBody>
+          <a:bodyPr wrap="square" lIns="73152" tIns="73152" rIns="73152" bIns="73152" anchor="t">
+            <a:noAutofit/>
+          </a:bodyPr>
+          <a:lstStyle/>
+          <a:p>
+            <a:pPr algn="l">
+              <a:buNone/>
+            </a:pPr>
+            <a:r>
+              <a:rPr lang="en-US" sz="1000" b="0" i="0" dirty="0">
+                <a:solidFill>
+                  <a:srgbClr val="9FB3C8"/>
                 </a:solidFill>
                 <a:latin typeface="Open Sans"/>
                 <a:cs typeface="Open Sans"/>
               </a:rPr>
-              <a:t>Was the robot told what it was doing? Missing or gibberish task text is flagged.</a:t>
-            </a:r>
-            <a:endParaRPr lang="en-US" sz="1300" dirty="0"/>
-          </a:p>
-        </p:txBody>
-      </p:sp>
-      <p:sp>
-        <p:nvSpPr>
-          <p:cNvPr id="13" name="Shape 13"/>
-          <p:cNvSpPr/>
-          <p:nvPr/>
-        </p:nvSpPr>
-        <p:spPr>
-          <a:xfrm>
-            <a:off x="6172200" y="2011680"/>
-            <a:ext cx="2560320" cy="2148840"/>
-          </a:xfrm>
-          <a:prstGeom prst="roundRect">
-            <a:avLst>
-              <a:gd name="adj" fmla="val 10000"/>
-            </a:avLst>
-          </a:prstGeom>
-          <a:solidFill>
-            <a:srgbClr val="151C26"/>
-          </a:solidFill>
-          <a:ln w="15875">
-            <a:solidFill>
-              <a:srgbClr val="23414A"/>
-            </a:solidFill>
-          </a:ln>
-        </p:spPr>
-        <p:txBody>
-          <a:bodyPr/>
-          <a:lstStyle/>
-          <a:p>
-            <a:endParaRPr lang="en-US"/>
-          </a:p>
-        </p:txBody>
-      </p:sp>
-      <p:sp>
-        <p:nvSpPr>
-          <p:cNvPr id="14" name="Shape 14"/>
-          <p:cNvSpPr/>
-          <p:nvPr/>
-        </p:nvSpPr>
-        <p:spPr>
-          <a:xfrm>
-            <a:off x="6172200" y="2176272"/>
-            <a:ext cx="64008" cy="1819656"/>
-          </a:xfrm>
-          <a:prstGeom prst="rect">
-            <a:avLst/>
-          </a:prstGeom>
-          <a:solidFill>
-            <a:srgbClr val="2DD4BF"/>
-          </a:solidFill>
-          <a:ln>
-            <a:noFill/>
-          </a:ln>
-        </p:spPr>
-        <p:txBody>
-          <a:bodyPr/>
-          <a:lstStyle/>
-          <a:p>
-            <a:endParaRPr lang="en-US"/>
-          </a:p>
-        </p:txBody>
-      </p:sp>
-      <p:sp>
-        <p:nvSpPr>
-          <p:cNvPr id="15" name="Text 15"/>
-          <p:cNvSpPr txBox="1"/>
-          <p:nvPr/>
-        </p:nvSpPr>
-        <p:spPr>
-          <a:xfrm>
-            <a:off x="6400800" y="2148840"/>
-            <a:ext cx="2194560" cy="457200"/>
-          </a:xfrm>
-          <a:prstGeom prst="rect">
-            <a:avLst/>
-          </a:prstGeom>
-          <a:noFill/>
-          <a:ln>
-            <a:noFill/>
-          </a:ln>
-        </p:spPr>
-        <p:txBody>
-          <a:bodyPr wrap="square" lIns="73152" tIns="73152" rIns="73152" bIns="73152" anchor="t">
-            <a:noAutofit/>
-          </a:bodyPr>
-          <a:lstStyle/>
-          <a:p>
-            <a:pPr algn="l">
-              <a:buNone/>
-            </a:pPr>
-            <a:r>
-              <a:rPr lang="en-US" sz="1700" b="1" i="0" dirty="0">
-                <a:solidFill>
-                  <a:srgbClr val="2DD4BF"/>
-                </a:solidFill>
-                <a:latin typeface="Montserrat"/>
-                <a:cs typeface="Montserrat"/>
-              </a:rPr>
-              <a:t>3  Unusualness</a:t>
-            </a:r>
-            <a:endParaRPr lang="en-US" sz="1700" dirty="0"/>
-          </a:p>
-        </p:txBody>
-      </p:sp>
-      <p:sp>
-        <p:nvSpPr>
-          <p:cNvPr id="16" name="Text 16"/>
-          <p:cNvSpPr txBox="1"/>
-          <p:nvPr/>
-        </p:nvSpPr>
-        <p:spPr>
-          <a:xfrm>
-            <a:off x="6400800" y="2578608"/>
-            <a:ext cx="2194560" cy="1463040"/>
-          </a:xfrm>
-          <a:prstGeom prst="rect">
-            <a:avLst/>
-          </a:prstGeom>
-          <a:noFill/>
-          <a:ln>
-            <a:noFill/>
-          </a:ln>
-        </p:spPr>
-        <p:txBody>
-          <a:bodyPr wrap="square" lIns="73152" tIns="73152" rIns="73152" bIns="73152" anchor="t">
-            <a:noAutofit/>
-          </a:bodyPr>
-          <a:lstStyle/>
-          <a:p>
-            <a:pPr algn="l">
-              <a:buNone/>
-            </a:pPr>
-            <a:r>
-              <a:rPr lang="en-US" sz="1300" b="0" i="0" dirty="0">
-                <a:solidFill>
-                  <a:srgbClr val="E6EDF3"/>
-                </a:solidFill>
-                <a:latin typeface="Open Sans"/>
-                <a:cs typeface="Open Sans"/>
-              </a:rPr>
-              <a:t>How different is it from known-good recordings of the same task? A rank, not a probability.</a:t>
-            </a:r>
-            <a:endParaRPr lang="en-US" sz="1300" dirty="0"/>
-          </a:p>
-        </p:txBody>
-      </p:sp>
-      <p:sp>
-        <p:nvSpPr>
-          <p:cNvPr id="17" name="Shape 17"/>
-          <p:cNvSpPr/>
-          <p:nvPr/>
-        </p:nvSpPr>
-        <p:spPr>
-          <a:xfrm>
-            <a:off x="8915400" y="2011680"/>
-            <a:ext cx="2560320" cy="2148840"/>
-          </a:xfrm>
-          <a:prstGeom prst="roundRect">
-            <a:avLst>
-              <a:gd name="adj" fmla="val 10000"/>
-            </a:avLst>
-          </a:prstGeom>
-          <a:solidFill>
-            <a:srgbClr val="151C26"/>
-          </a:solidFill>
-          <a:ln w="15875">
-            <a:solidFill>
-              <a:srgbClr val="23414A"/>
-            </a:solidFill>
-          </a:ln>
-        </p:spPr>
-        <p:txBody>
-          <a:bodyPr/>
-          <a:lstStyle/>
-          <a:p>
-            <a:endParaRPr lang="en-US"/>
-          </a:p>
-        </p:txBody>
-      </p:sp>
-      <p:sp>
-        <p:nvSpPr>
-          <p:cNvPr id="18" name="Shape 18"/>
-          <p:cNvSpPr/>
-          <p:nvPr/>
-        </p:nvSpPr>
-        <p:spPr>
-          <a:xfrm>
-            <a:off x="8915400" y="2176272"/>
-            <a:ext cx="64008" cy="1819656"/>
-          </a:xfrm>
-          <a:prstGeom prst="rect">
-            <a:avLst/>
-          </a:prstGeom>
-          <a:solidFill>
-            <a:srgbClr val="2DD4BF"/>
-          </a:solidFill>
-          <a:ln>
-            <a:noFill/>
-          </a:ln>
-        </p:spPr>
-        <p:txBody>
-          <a:bodyPr/>
-          <a:lstStyle/>
-          <a:p>
-            <a:endParaRPr lang="en-US"/>
-          </a:p>
-        </p:txBody>
-      </p:sp>
-      <p:sp>
-        <p:nvSpPr>
-          <p:cNvPr id="19" name="Text 19"/>
-          <p:cNvSpPr txBox="1"/>
-          <p:nvPr/>
-        </p:nvSpPr>
-        <p:spPr>
-          <a:xfrm>
-            <a:off x="9144000" y="2148840"/>
-            <a:ext cx="2194560" cy="457200"/>
-          </a:xfrm>
-          <a:prstGeom prst="rect">
-            <a:avLst/>
-          </a:prstGeom>
-          <a:noFill/>
-          <a:ln>
-            <a:noFill/>
-          </a:ln>
-        </p:spPr>
-        <p:txBody>
-          <a:bodyPr wrap="square" lIns="73152" tIns="73152" rIns="73152" bIns="73152" anchor="t">
-            <a:noAutofit/>
-          </a:bodyPr>
-          <a:lstStyle/>
-          <a:p>
-            <a:pPr algn="l">
-              <a:buNone/>
-            </a:pPr>
-            <a:r>
-              <a:rPr lang="en-US" sz="1700" b="1" i="0" dirty="0">
-                <a:solidFill>
-                  <a:srgbClr val="2DD4BF"/>
-                </a:solidFill>
-                <a:latin typeface="Montserrat"/>
-                <a:cs typeface="Montserrat"/>
-              </a:rPr>
-              <a:t>4  Route + log</a:t>
-            </a:r>
-            <a:endParaRPr lang="en-US" sz="1700" dirty="0"/>
-          </a:p>
-        </p:txBody>
-      </p:sp>
-      <p:sp>
-        <p:nvSpPr>
-          <p:cNvPr id="20" name="Text 20"/>
-          <p:cNvSpPr txBox="1"/>
-          <p:nvPr/>
-        </p:nvSpPr>
-        <p:spPr>
-          <a:xfrm>
-            <a:off x="9144000" y="2578608"/>
-            <a:ext cx="2194560" cy="1463040"/>
-          </a:xfrm>
-          <a:prstGeom prst="rect">
-            <a:avLst/>
-          </a:prstGeom>
-          <a:noFill/>
-          <a:ln>
-            <a:noFill/>
-          </a:ln>
-        </p:spPr>
-        <p:txBody>
-          <a:bodyPr wrap="square" lIns="73152" tIns="73152" rIns="73152" bIns="73152" anchor="t">
-            <a:noAutofit/>
-          </a:bodyPr>
-          <a:lstStyle/>
-          <a:p>
-            <a:pPr algn="l">
-              <a:buNone/>
-            </a:pPr>
-            <a:r>
-              <a:rPr lang="en-US" sz="1300" b="0" i="0" dirty="0">
-                <a:solidFill>
-                  <a:srgbClr val="E6EDF3"/>
-                </a:solidFill>
-                <a:latin typeface="Open Sans"/>
-                <a:cs typeface="Open Sans"/>
-              </a:rPr>
-              <a:t>Accept, review or reject, and record why. History is never overwritten.</a:t>
-            </a:r>
-            <a:endParaRPr lang="en-US" sz="1300" dirty="0"/>
-          </a:p>
-        </p:txBody>
-      </p:sp>
-      <p:sp>
-        <p:nvSpPr>
-          <p:cNvPr id="21" name="Text 21"/>
-          <p:cNvSpPr txBox="1"/>
-          <p:nvPr/>
-        </p:nvSpPr>
-        <p:spPr>
-          <a:xfrm>
-            <a:off x="685800" y="4526280"/>
-            <a:ext cx="10789920" cy="822960"/>
-          </a:xfrm>
-          <a:prstGeom prst="rect">
-            <a:avLst/>
-          </a:prstGeom>
-          <a:noFill/>
-          <a:ln>
-            <a:noFill/>
-          </a:ln>
-        </p:spPr>
-        <p:txBody>
-          <a:bodyPr wrap="square" lIns="73152" tIns="73152" rIns="73152" bIns="73152" anchor="t">
-            <a:noAutofit/>
-          </a:bodyPr>
-          <a:lstStyle/>
-          <a:p>
-            <a:pPr algn="l">
-              <a:buNone/>
-            </a:pPr>
-            <a:r>
-              <a:rPr lang="en-US" sz="1500" b="1" i="0" dirty="0">
-                <a:solidFill>
-                  <a:srgbClr val="2DD4BF"/>
-                </a:solidFill>
-                <a:latin typeface="Open Sans"/>
-                <a:cs typeface="Open Sans"/>
-              </a:rPr>
-              <a:t>Works live too: </a:t>
-            </a:r>
-            <a:r>
-              <a:rPr lang="en-US" sz="1500" b="0" i="0" dirty="0">
-                <a:solidFill>
-                  <a:srgbClr val="E6EDF3"/>
-                </a:solidFill>
-                <a:latin typeface="Open Sans"/>
-                <a:cs typeface="Open Sans"/>
-              </a:rPr>
-              <a:t>a collector adapter streams frames from a running robot into the same gate, and per-robot profiles store each rig's expected rate and limits.</a:t>
-            </a:r>
-            <a:endParaRPr lang="en-US" sz="1500" dirty="0"/>
-          </a:p>
-        </p:txBody>
-      </p:sp>
-      <p:sp>
-        <p:nvSpPr>
-          <p:cNvPr id="22" name="Shape 22"/>
-          <p:cNvSpPr/>
-          <p:nvPr/>
-        </p:nvSpPr>
-        <p:spPr>
-          <a:xfrm>
-            <a:off x="685800" y="6419088"/>
-            <a:ext cx="502920" cy="45720"/>
-          </a:xfrm>
-          <a:prstGeom prst="rect">
-            <a:avLst/>
-          </a:prstGeom>
-          <a:solidFill>
-            <a:srgbClr val="2DD4BF"/>
-          </a:solidFill>
-          <a:ln>
-            <a:noFill/>
-          </a:ln>
-        </p:spPr>
-        <p:txBody>
-          <a:bodyPr/>
-          <a:lstStyle/>
-          <a:p>
-            <a:endParaRPr lang="en-US"/>
-          </a:p>
-        </p:txBody>
-      </p:sp>
-      <p:sp>
-        <p:nvSpPr>
-          <p:cNvPr id="23" name="Text 23"/>
-          <p:cNvSpPr txBox="1"/>
-          <p:nvPr/>
-        </p:nvSpPr>
-        <p:spPr>
-          <a:xfrm>
-            <a:off x="1280160" y="6272784"/>
-            <a:ext cx="5486400" cy="320040"/>
-          </a:xfrm>
-          <a:prstGeom prst="rect">
-            <a:avLst/>
-          </a:prstGeom>
-          <a:noFill/>
-          <a:ln>
-            <a:noFill/>
-          </a:ln>
-        </p:spPr>
-        <p:txBody>
-          <a:bodyPr wrap="square" lIns="73152" tIns="73152" rIns="73152" bIns="73152" anchor="t">
-            <a:noAutofit/>
-          </a:bodyPr>
-          <a:lstStyle/>
-          <a:p>
-            <a:pPr algn="l">
-              <a:buNone/>
-            </a:pPr>
-            <a:r>
-              <a:rPr lang="en-US" sz="1000" b="0" i="0" dirty="0">
-                <a:solidFill>
-                  <a:srgbClr val="9FB3C8"/>
-                </a:solidFill>
-                <a:latin typeface="Open Sans"/>
-                <a:cs typeface="Open Sans"/>
-              </a:rPr>
               <a:t>DataMon  ·  Hackachusetts  ·  Robotics &amp; Hardware</a:t>
             </a:r>
             <a:endParaRPr lang="en-US" sz="1000" dirty="0"/>
@@ -3416,7 +3492,7 @@
       </p:sp>
       <p:sp>
         <p:nvSpPr>
-          <p:cNvPr id="24" name="Text 24"/>
+          <p:cNvPr id="22" name="Text 22"/>
           <p:cNvSpPr txBox="1"/>
           <p:nvPr/>
         </p:nvSpPr>
@@ -3489,87 +3565,69 @@
           <a:chExt cx="0" cy="0"/>
         </a:xfrm>
       </p:grpSpPr>
-      <p:sp>
-        <p:nvSpPr>
-          <p:cNvPr id="3" name="Text 3"/>
-          <p:cNvSpPr txBox="1"/>
-          <p:nvPr/>
-        </p:nvSpPr>
-        <p:spPr>
-          <a:xfrm>
-            <a:off x="685800" y="1463040"/>
-            <a:ext cx="10789920" cy="457200"/>
-          </a:xfrm>
-          <a:prstGeom prst="rect">
-            <a:avLst/>
-          </a:prstGeom>
-          <a:noFill/>
-          <a:ln>
-            <a:noFill/>
-          </a:ln>
-        </p:spPr>
-        <p:txBody>
-          <a:bodyPr wrap="square" lIns="73152" tIns="73152" rIns="73152" bIns="73152" anchor="t">
-            <a:noAutofit/>
-          </a:bodyPr>
-          <a:lstStyle/>
-          <a:p>
-            <a:pPr algn="ctr">
-              <a:buNone/>
-            </a:pPr>
-            <a:r>
-              <a:rPr lang="en-US" sz="1600" b="1" i="0" dirty="0">
-                <a:solidFill>
-                  <a:srgbClr val="2DD4BF"/>
+      <p:pic>
+        <p:nvPicPr>
+          <p:cNvPr id="3" name="mascot.png"/>
+          <p:cNvPicPr>
+            <a:picLocks noChangeAspect="1"/>
+          </p:cNvPicPr>
+          <p:nvPr/>
+        </p:nvPicPr>
+        <p:blipFill>
+          <a:blip r:embed="rId3"/>
+          <a:stretch>
+            <a:fillRect/>
+          </a:stretch>
+        </p:blipFill>
+        <p:spPr>
+          <a:xfrm>
+            <a:off x="777240" y="914400"/>
+            <a:ext cx="1463040" cy="1463040"/>
+          </a:xfrm>
+          <a:prstGeom prst="rect">
+            <a:avLst/>
+          </a:prstGeom>
+        </p:spPr>
+      </p:pic>
+      <p:sp>
+        <p:nvSpPr>
+          <p:cNvPr id="4" name="Text 4"/>
+          <p:cNvSpPr txBox="1"/>
+          <p:nvPr/>
+        </p:nvSpPr>
+        <p:spPr>
+          <a:xfrm>
+            <a:off x="2468880" y="960120"/>
+            <a:ext cx="4572000" cy="914400"/>
+          </a:xfrm>
+          <a:prstGeom prst="rect">
+            <a:avLst/>
+          </a:prstGeom>
+          <a:noFill/>
+          <a:ln>
+            <a:noFill/>
+          </a:ln>
+        </p:spPr>
+        <p:txBody>
+          <a:bodyPr wrap="square" lIns="73152" tIns="73152" rIns="73152" bIns="73152" anchor="t">
+            <a:noAutofit/>
+          </a:bodyPr>
+          <a:lstStyle/>
+          <a:p>
+            <a:pPr algn="l">
+              <a:buNone/>
+            </a:pPr>
+            <a:r>
+              <a:rPr lang="en-US" sz="4000" b="1" i="0" dirty="0">
+                <a:solidFill>
+                  <a:srgbClr val="E6EDF3"/>
                 </a:solidFill>
                 <a:latin typeface="Montserrat"/>
                 <a:cs typeface="Montserrat"/>
               </a:rPr>
-              <a:t>LIVE DEMO</a:t>
-            </a:r>
-            <a:endParaRPr lang="en-US" sz="1600" dirty="0"/>
-          </a:p>
-        </p:txBody>
-      </p:sp>
-      <p:sp>
-        <p:nvSpPr>
-          <p:cNvPr id="4" name="Text 4"/>
-          <p:cNvSpPr txBox="1"/>
-          <p:nvPr/>
-        </p:nvSpPr>
-        <p:spPr>
-          <a:xfrm>
-            <a:off x="685800" y="1920240"/>
-            <a:ext cx="10789920" cy="1097280"/>
-          </a:xfrm>
-          <a:prstGeom prst="rect">
-            <a:avLst/>
-          </a:prstGeom>
-          <a:noFill/>
-          <a:ln>
-            <a:noFill/>
-          </a:ln>
-        </p:spPr>
-        <p:txBody>
-          <a:bodyPr wrap="square" lIns="73152" tIns="73152" rIns="73152" bIns="73152" anchor="t">
-            <a:noAutofit/>
-          </a:bodyPr>
-          <a:lstStyle/>
-          <a:p>
-            <a:pPr algn="ctr">
-              <a:buNone/>
-            </a:pPr>
-            <a:r>
-              <a:rPr lang="en-US" sz="4800" b="1" i="0" dirty="0">
-                <a:solidFill>
-                  <a:srgbClr val="E6EDF3"/>
-                </a:solidFill>
-                <a:latin typeface="Montserrat"/>
-                <a:cs typeface="Montserrat"/>
-              </a:rPr>
-              <a:t>See it working</a:t>
-            </a:r>
-            <a:endParaRPr lang="en-US" sz="4800" dirty="0"/>
+              <a:t>Try DataMon</a:t>
+            </a:r>
+            <a:endParaRPr lang="en-US" sz="4000" dirty="0"/>
           </a:p>
         </p:txBody>
       </p:sp>
@@ -3581,8 +3639,50 @@
         </p:nvSpPr>
         <p:spPr>
           <a:xfrm>
-            <a:off x="2651760" y="3291840"/>
-            <a:ext cx="6858000" cy="1463040"/>
+            <a:off x="2468880" y="1691640"/>
+            <a:ext cx="4572000" cy="548640"/>
+          </a:xfrm>
+          <a:prstGeom prst="rect">
+            <a:avLst/>
+          </a:prstGeom>
+          <a:noFill/>
+          <a:ln>
+            <a:noFill/>
+          </a:ln>
+        </p:spPr>
+        <p:txBody>
+          <a:bodyPr wrap="square" lIns="73152" tIns="73152" rIns="73152" bIns="73152" anchor="t">
+            <a:noAutofit/>
+          </a:bodyPr>
+          <a:lstStyle/>
+          <a:p>
+            <a:pPr algn="l">
+              <a:buNone/>
+            </a:pPr>
+            <a:r>
+              <a:rPr lang="en-US" sz="2000" b="0" i="1" dirty="0">
+                <a:solidFill>
+                  <a:srgbClr val="2DD4BF"/>
+                </a:solidFill>
+                <a:latin typeface="Open Sans"/>
+                <a:cs typeface="Open Sans"/>
+              </a:rPr>
+              <a:t>Good data in. Bad data out.</a:t>
+            </a:r>
+            <a:endParaRPr lang="en-US" sz="2000" dirty="0"/>
+          </a:p>
+        </p:txBody>
+      </p:sp>
+      <p:sp>
+        <p:nvSpPr>
+          <p:cNvPr id="6" name="Text 6"/>
+          <p:cNvSpPr txBox="1"/>
+          <p:nvPr/>
+        </p:nvSpPr>
+        <p:spPr>
+          <a:xfrm>
+            <a:off x="777240" y="2743200"/>
+            <a:ext cx="5760720" cy="2468880"/>
           </a:xfrm>
           <a:prstGeom prst="roundRect">
             <a:avLst>
@@ -3599,16 +3699,35 @@
           </a:ln>
         </p:spPr>
         <p:txBody>
-          <a:bodyPr wrap="square" lIns="73152" tIns="73152" rIns="73152" bIns="73152" anchor="ctr">
-            <a:noAutofit/>
-          </a:bodyPr>
-          <a:lstStyle/>
-          <a:p>
-            <a:pPr algn="ctr">
-              <a:buNone/>
-            </a:pPr>
-            <a:r>
-              <a:rPr lang="en-US" sz="2200" b="1" i="0" dirty="0">
+          <a:bodyPr wrap="square" lIns="228600" tIns="228600" rIns="228600" bIns="228600" anchor="t">
+            <a:noAutofit/>
+          </a:bodyPr>
+          <a:lstStyle/>
+          <a:p>
+            <a:pPr algn="l">
+              <a:buNone/>
+            </a:pPr>
+            <a:r>
+              <a:rPr lang="en-US" sz="1200" b="1" i="0" dirty="0">
+                <a:solidFill>
+                  <a:srgbClr val="9FB3C8"/>
+                </a:solidFill>
+                <a:latin typeface="Montserrat"/>
+                <a:cs typeface="Montserrat"/>
+              </a:rPr>
+              <a:t>LIVE SITE</a:t>
+            </a:r>
+            <a:endParaRPr lang="en-US" sz="1200" dirty="0"/>
+          </a:p>
+          <a:p>
+            <a:pPr algn="l">
+              <a:spcBef>
+                <a:spcPts val="200"/>
+              </a:spcBef>
+              <a:buNone/>
+            </a:pPr>
+            <a:r>
+              <a:rPr lang="en-US" sz="1700" b="1" i="0" dirty="0">
                 <a:solidFill>
                   <a:srgbClr val="2DD4BF"/>
                 </a:solidFill>
@@ -3617,74 +3736,197 @@
               </a:rPr>
               <a:t>hackachusetts-datamon.streamlit.app</a:t>
             </a:r>
-            <a:endParaRPr lang="en-US" sz="2200" dirty="0"/>
-          </a:p>
-          <a:p>
-            <a:pPr algn="ctr">
+            <a:endParaRPr lang="en-US" sz="1700" dirty="0"/>
+          </a:p>
+          <a:p>
+            <a:pPr algn="l">
               <a:spcBef>
-                <a:spcPts val="1000"/>
+                <a:spcPts val="1400"/>
               </a:spcBef>
               <a:buNone/>
             </a:pPr>
             <a:r>
-              <a:rPr lang="en-US" sz="1800" b="0" i="0" dirty="0">
+              <a:rPr lang="en-US" sz="1200" b="1" i="0" dirty="0">
+                <a:solidFill>
+                  <a:srgbClr val="9FB3C8"/>
+                </a:solidFill>
+                <a:latin typeface="Montserrat"/>
+                <a:cs typeface="Montserrat"/>
+              </a:rPr>
+              <a:t>SIGN IN</a:t>
+            </a:r>
+            <a:endParaRPr lang="en-US" sz="1200" dirty="0"/>
+          </a:p>
+          <a:p>
+            <a:pPr algn="l">
+              <a:spcBef>
+                <a:spcPts val="200"/>
+              </a:spcBef>
+              <a:buNone/>
+            </a:pPr>
+            <a:r>
+              <a:rPr lang="en-US" sz="1700" b="1" i="0" dirty="0">
                 <a:solidFill>
                   <a:srgbClr val="E6EDF3"/>
                 </a:solidFill>
                 <a:latin typeface="Open Sans"/>
                 <a:cs typeface="Open Sans"/>
               </a:rPr>
-              <a:t>Sign in:  judge  /  Hello World!</a:t>
-            </a:r>
-            <a:endParaRPr lang="en-US" sz="1800" dirty="0"/>
-          </a:p>
-        </p:txBody>
-      </p:sp>
-      <p:sp>
-        <p:nvSpPr>
-          <p:cNvPr id="6" name="Text 6"/>
-          <p:cNvSpPr txBox="1"/>
-          <p:nvPr/>
-        </p:nvSpPr>
-        <p:spPr>
-          <a:xfrm>
-            <a:off x="685800" y="5120640"/>
-            <a:ext cx="10789920" cy="548640"/>
-          </a:xfrm>
-          <a:prstGeom prst="rect">
-            <a:avLst/>
-          </a:prstGeom>
-          <a:noFill/>
-          <a:ln>
-            <a:noFill/>
-          </a:ln>
-        </p:spPr>
-        <p:txBody>
-          <a:bodyPr wrap="square" lIns="73152" tIns="73152" rIns="73152" bIns="73152" anchor="t">
-            <a:noAutofit/>
-          </a:bodyPr>
-          <a:lstStyle/>
-          <a:p>
-            <a:pPr algn="ctr">
-              <a:buNone/>
-            </a:pPr>
-            <a:r>
-              <a:rPr lang="en-US" sz="1500" b="0" i="0" dirty="0">
+              <a:t>judge  /  Hello World!</a:t>
+            </a:r>
+            <a:endParaRPr lang="en-US" sz="1700" dirty="0"/>
+          </a:p>
+          <a:p>
+            <a:pPr algn="l">
+              <a:spcBef>
+                <a:spcPts val="1400"/>
+              </a:spcBef>
+              <a:buNone/>
+            </a:pPr>
+            <a:r>
+              <a:rPr lang="en-US" sz="1200" b="1" i="0" dirty="0">
                 <a:solidFill>
                   <a:srgbClr val="9FB3C8"/>
+                </a:solidFill>
+                <a:latin typeface="Montserrat"/>
+                <a:cs typeface="Montserrat"/>
+              </a:rPr>
+              <a:t>CODE + KIRO SPECS</a:t>
+            </a:r>
+            <a:endParaRPr lang="en-US" sz="1200" dirty="0"/>
+          </a:p>
+          <a:p>
+            <a:pPr algn="l">
+              <a:spcBef>
+                <a:spcPts val="200"/>
+              </a:spcBef>
+              <a:buNone/>
+            </a:pPr>
+            <a:r>
+              <a:rPr lang="en-US" sz="1700" b="1" i="0" dirty="0">
+                <a:solidFill>
+                  <a:srgbClr val="2DD4BF"/>
                 </a:solidFill>
                 <a:latin typeface="Open Sans"/>
                 <a:cs typeface="Open Sans"/>
               </a:rPr>
-              <a:t>Real public data: 100 DROID recordings and a BridgeData V2 sample, in the open LeRobot format.</a:t>
-            </a:r>
-            <a:endParaRPr lang="en-US" sz="1500" dirty="0"/>
-          </a:p>
-        </p:txBody>
-      </p:sp>
-      <p:sp>
-        <p:nvSpPr>
-          <p:cNvPr id="7" name="Shape 7"/>
+              <a:t>github.com/AZALAH/HackachusettsR3</a:t>
+            </a:r>
+            <a:endParaRPr lang="en-US" sz="1700" dirty="0"/>
+          </a:p>
+        </p:txBody>
+      </p:sp>
+      <p:pic>
+        <p:nvPicPr>
+          <p:cNvPr id="7" name="login.png"/>
+          <p:cNvPicPr>
+            <a:picLocks noChangeAspect="1"/>
+          </p:cNvPicPr>
+          <p:nvPr/>
+        </p:nvPicPr>
+        <p:blipFill>
+          <a:blip r:embed="rId4"/>
+          <a:stretch>
+            <a:fillRect/>
+          </a:stretch>
+        </p:blipFill>
+        <p:spPr>
+          <a:xfrm>
+            <a:off x="6812280" y="960120"/>
+            <a:ext cx="4709160" cy="2996738"/>
+          </a:xfrm>
+          <a:prstGeom prst="rect">
+            <a:avLst/>
+          </a:prstGeom>
+        </p:spPr>
+      </p:pic>
+      <p:sp>
+        <p:nvSpPr>
+          <p:cNvPr id="8" name="Text 8"/>
+          <p:cNvSpPr txBox="1"/>
+          <p:nvPr/>
+        </p:nvSpPr>
+        <p:spPr>
+          <a:xfrm>
+            <a:off x="6812280" y="4069080"/>
+            <a:ext cx="4709160" cy="457200"/>
+          </a:xfrm>
+          <a:prstGeom prst="rect">
+            <a:avLst/>
+          </a:prstGeom>
+          <a:noFill/>
+          <a:ln>
+            <a:noFill/>
+          </a:ln>
+        </p:spPr>
+        <p:txBody>
+          <a:bodyPr wrap="square" lIns="73152" tIns="73152" rIns="73152" bIns="73152" anchor="t">
+            <a:noAutofit/>
+          </a:bodyPr>
+          <a:lstStyle/>
+          <a:p>
+            <a:pPr algn="ctr">
+              <a:buNone/>
+            </a:pPr>
+            <a:r>
+              <a:rPr lang="en-US" sz="1200" b="0" i="1" dirty="0">
+                <a:solidFill>
+                  <a:srgbClr val="9FB3C8"/>
+                </a:solidFill>
+                <a:latin typeface="Open Sans"/>
+                <a:cs typeface="Open Sans"/>
+              </a:rPr>
+              <a:t>The DataMon sign-in page</a:t>
+            </a:r>
+            <a:endParaRPr lang="en-US" sz="1200" dirty="0"/>
+          </a:p>
+        </p:txBody>
+      </p:sp>
+      <p:sp>
+        <p:nvSpPr>
+          <p:cNvPr id="9" name="Text 9"/>
+          <p:cNvSpPr txBox="1"/>
+          <p:nvPr/>
+        </p:nvSpPr>
+        <p:spPr>
+          <a:xfrm>
+            <a:off x="6812280" y="4846320"/>
+            <a:ext cx="4709160" cy="822960"/>
+          </a:xfrm>
+          <a:prstGeom prst="rect">
+            <a:avLst/>
+          </a:prstGeom>
+          <a:noFill/>
+          <a:ln>
+            <a:noFill/>
+          </a:ln>
+        </p:spPr>
+        <p:txBody>
+          <a:bodyPr wrap="square" lIns="73152" tIns="73152" rIns="73152" bIns="73152" anchor="t">
+            <a:noAutofit/>
+          </a:bodyPr>
+          <a:lstStyle/>
+          <a:p>
+            <a:pPr algn="ctr">
+              <a:buNone/>
+            </a:pPr>
+            <a:r>
+              <a:rPr lang="en-US" sz="3000" b="1" i="0" dirty="0">
+                <a:solidFill>
+                  <a:srgbClr val="E6EDF3"/>
+                </a:solidFill>
+                <a:latin typeface="Montserrat"/>
+                <a:cs typeface="Montserrat"/>
+              </a:rPr>
+              <a:t>Thank you!</a:t>
+            </a:r>
+            <a:endParaRPr lang="en-US" sz="3000" dirty="0"/>
+          </a:p>
+        </p:txBody>
+      </p:sp>
+      <p:sp>
+        <p:nvSpPr>
+          <p:cNvPr id="10" name="Shape 10"/>
           <p:cNvSpPr/>
           <p:nvPr/>
         </p:nvSpPr>
@@ -3713,7 +3955,7 @@
       </p:sp>
       <p:sp>
         <p:nvSpPr>
-          <p:cNvPr id="8" name="Text 8"/>
+          <p:cNvPr id="11" name="Text 11"/>
           <p:cNvSpPr txBox="1"/>
           <p:nvPr/>
         </p:nvSpPr>
@@ -3755,7 +3997,7 @@
       </p:sp>
       <p:sp>
         <p:nvSpPr>
-          <p:cNvPr id="9" name="Text 9"/>
+          <p:cNvPr id="12" name="Text 12"/>
           <p:cNvSpPr txBox="1"/>
           <p:nvPr/>
         </p:nvSpPr>
@@ -3864,7 +4106,7 @@
                 <a:latin typeface="Montserrat"/>
                 <a:cs typeface="Montserrat"/>
               </a:rPr>
-              <a:t>BUILT FOR EVERYONE</a:t>
+              <a:t>HOW IT WORKS</a:t>
             </a:r>
             <a:endParaRPr lang="en-US" sz="1300" dirty="0"/>
           </a:p>
@@ -3906,7 +4148,7 @@
                 <a:latin typeface="Montserrat"/>
                 <a:cs typeface="Montserrat"/>
               </a:rPr>
-              <a:t>Accessible, and fun to use</a:t>
+              <a:t>Four checks, in plain terms</a:t>
             </a:r>
             <a:endParaRPr lang="en-US" sz="3400" dirty="0"/>
           </a:p>
@@ -3914,416 +4156,47 @@
       </p:sp>
       <p:sp>
         <p:nvSpPr>
-          <p:cNvPr id="5" name="Text 5"/>
-          <p:cNvSpPr txBox="1"/>
-          <p:nvPr/>
-        </p:nvSpPr>
-        <p:spPr>
-          <a:xfrm>
-            <a:off x="685800" y="1783080"/>
-            <a:ext cx="5760720" cy="411480"/>
-          </a:xfrm>
-          <a:prstGeom prst="rect">
-            <a:avLst/>
-          </a:prstGeom>
-          <a:noFill/>
-          <a:ln>
-            <a:noFill/>
-          </a:ln>
-        </p:spPr>
-        <p:txBody>
-          <a:bodyPr wrap="square" lIns="73152" tIns="73152" rIns="73152" bIns="73152" anchor="t">
-            <a:noAutofit/>
-          </a:bodyPr>
-          <a:lstStyle/>
-          <a:p>
-            <a:pPr algn="l">
-              <a:buNone/>
-            </a:pPr>
-            <a:r>
-              <a:rPr lang="en-US" sz="1800" b="1" i="0" dirty="0">
-                <a:solidFill>
-                  <a:srgbClr val="2DD4BF"/>
-                </a:solidFill>
-                <a:latin typeface="Montserrat"/>
-                <a:cs typeface="Montserrat"/>
-              </a:rPr>
-              <a:t>Narrated guided tour</a:t>
-            </a:r>
-            <a:endParaRPr lang="en-US" sz="1800" dirty="0"/>
-          </a:p>
-        </p:txBody>
-      </p:sp>
-      <p:sp>
-        <p:nvSpPr>
-          <p:cNvPr id="6" name="Text 6"/>
-          <p:cNvSpPr txBox="1"/>
-          <p:nvPr/>
-        </p:nvSpPr>
-        <p:spPr>
-          <a:xfrm>
-            <a:off x="685800" y="2167128"/>
-            <a:ext cx="5760720" cy="640080"/>
-          </a:xfrm>
-          <a:prstGeom prst="rect">
-            <a:avLst/>
-          </a:prstGeom>
-          <a:noFill/>
-          <a:ln>
-            <a:noFill/>
-          </a:ln>
-        </p:spPr>
-        <p:txBody>
-          <a:bodyPr wrap="square" lIns="73152" tIns="73152" rIns="73152" bIns="73152" anchor="t">
-            <a:noAutofit/>
-          </a:bodyPr>
-          <a:lstStyle/>
-          <a:p>
-            <a:pPr algn="l">
-              <a:buNone/>
-            </a:pPr>
-            <a:r>
-              <a:rPr lang="en-US" sz="1350" b="0" i="0" dirty="0">
-                <a:solidFill>
-                  <a:srgbClr val="E6EDF3"/>
-                </a:solidFill>
-                <a:latin typeface="Open Sans"/>
-                <a:cs typeface="Open Sans"/>
-              </a:rPr>
-              <a:t>11 steps. Voice, captions and a pointing arrow, so it works with or without sound.</a:t>
-            </a:r>
-            <a:endParaRPr lang="en-US" sz="1350" dirty="0"/>
-          </a:p>
-        </p:txBody>
-      </p:sp>
-      <p:sp>
-        <p:nvSpPr>
-          <p:cNvPr id="7" name="Text 7"/>
-          <p:cNvSpPr txBox="1"/>
-          <p:nvPr/>
-        </p:nvSpPr>
-        <p:spPr>
-          <a:xfrm>
-            <a:off x="685800" y="2862072"/>
-            <a:ext cx="5760720" cy="411480"/>
-          </a:xfrm>
-          <a:prstGeom prst="rect">
-            <a:avLst/>
-          </a:prstGeom>
-          <a:noFill/>
-          <a:ln>
-            <a:noFill/>
-          </a:ln>
-        </p:spPr>
-        <p:txBody>
-          <a:bodyPr wrap="square" lIns="73152" tIns="73152" rIns="73152" bIns="73152" anchor="t">
-            <a:noAutofit/>
-          </a:bodyPr>
-          <a:lstStyle/>
-          <a:p>
-            <a:pPr algn="l">
-              <a:buNone/>
-            </a:pPr>
-            <a:r>
-              <a:rPr lang="en-US" sz="1800" b="1" i="0" dirty="0">
-                <a:solidFill>
-                  <a:srgbClr val="2DD4BF"/>
-                </a:solidFill>
-                <a:latin typeface="Montserrat"/>
-                <a:cs typeface="Montserrat"/>
-              </a:rPr>
-              <a:t>Grounded help assistant</a:t>
-            </a:r>
-            <a:endParaRPr lang="en-US" sz="1800" dirty="0"/>
-          </a:p>
-        </p:txBody>
-      </p:sp>
-      <p:sp>
-        <p:nvSpPr>
-          <p:cNvPr id="8" name="Text 8"/>
-          <p:cNvSpPr txBox="1"/>
-          <p:nvPr/>
-        </p:nvSpPr>
-        <p:spPr>
-          <a:xfrm>
-            <a:off x="685800" y="3246120"/>
-            <a:ext cx="5760720" cy="640080"/>
-          </a:xfrm>
-          <a:prstGeom prst="rect">
-            <a:avLst/>
-          </a:prstGeom>
-          <a:noFill/>
-          <a:ln>
-            <a:noFill/>
-          </a:ln>
-        </p:spPr>
-        <p:txBody>
-          <a:bodyPr wrap="square" lIns="73152" tIns="73152" rIns="73152" bIns="73152" anchor="t">
-            <a:noAutofit/>
-          </a:bodyPr>
-          <a:lstStyle/>
-          <a:p>
-            <a:pPr algn="l">
-              <a:buNone/>
-            </a:pPr>
-            <a:r>
-              <a:rPr lang="en-US" sz="1350" b="0" i="0" dirty="0">
-                <a:solidFill>
-                  <a:srgbClr val="E6EDF3"/>
-                </a:solidFill>
-                <a:latin typeface="Open Sans"/>
-                <a:cs typeface="Open Sans"/>
-              </a:rPr>
-              <a:t>Answers only from DataMon's own docs, so it never invents an answer.</a:t>
-            </a:r>
-            <a:endParaRPr lang="en-US" sz="1350" dirty="0"/>
-          </a:p>
-        </p:txBody>
-      </p:sp>
-      <p:sp>
-        <p:nvSpPr>
-          <p:cNvPr id="9" name="Text 9"/>
-          <p:cNvSpPr txBox="1"/>
-          <p:nvPr/>
-        </p:nvSpPr>
-        <p:spPr>
-          <a:xfrm>
-            <a:off x="685800" y="3941064"/>
-            <a:ext cx="5760720" cy="411480"/>
-          </a:xfrm>
-          <a:prstGeom prst="rect">
-            <a:avLst/>
-          </a:prstGeom>
-          <a:noFill/>
-          <a:ln>
-            <a:noFill/>
-          </a:ln>
-        </p:spPr>
-        <p:txBody>
-          <a:bodyPr wrap="square" lIns="73152" tIns="73152" rIns="73152" bIns="73152" anchor="t">
-            <a:noAutofit/>
-          </a:bodyPr>
-          <a:lstStyle/>
-          <a:p>
-            <a:pPr algn="l">
-              <a:buNone/>
-            </a:pPr>
-            <a:r>
-              <a:rPr lang="en-US" sz="1800" b="1" i="0" dirty="0">
-                <a:solidFill>
-                  <a:srgbClr val="2DD4BF"/>
-                </a:solidFill>
-                <a:latin typeface="Montserrat"/>
-                <a:cs typeface="Montserrat"/>
-              </a:rPr>
-              <a:t>See it and hear it</a:t>
-            </a:r>
-            <a:endParaRPr lang="en-US" sz="1800" dirty="0"/>
-          </a:p>
-        </p:txBody>
-      </p:sp>
-      <p:sp>
-        <p:nvSpPr>
-          <p:cNvPr id="10" name="Text 10"/>
-          <p:cNvSpPr txBox="1"/>
-          <p:nvPr/>
-        </p:nvSpPr>
-        <p:spPr>
-          <a:xfrm>
-            <a:off x="685800" y="4325112"/>
-            <a:ext cx="5760720" cy="640080"/>
-          </a:xfrm>
-          <a:prstGeom prst="rect">
-            <a:avLst/>
-          </a:prstGeom>
-          <a:noFill/>
-          <a:ln>
-            <a:noFill/>
-          </a:ln>
-        </p:spPr>
-        <p:txBody>
-          <a:bodyPr wrap="square" lIns="73152" tIns="73152" rIns="73152" bIns="73152" anchor="t">
-            <a:noAutofit/>
-          </a:bodyPr>
-          <a:lstStyle/>
-          <a:p>
-            <a:pPr algn="l">
-              <a:buNone/>
-            </a:pPr>
-            <a:r>
-              <a:rPr lang="en-US" sz="1350" b="0" i="0" dirty="0">
-                <a:solidFill>
-                  <a:srgbClr val="E6EDF3"/>
-                </a:solidFill>
-                <a:latin typeface="Open Sans"/>
-                <a:cs typeface="Open Sans"/>
-              </a:rPr>
-              <a:t>Rejections show a colour-coded verdict and play an alert sound.</a:t>
-            </a:r>
-            <a:endParaRPr lang="en-US" sz="1350" dirty="0"/>
-          </a:p>
-        </p:txBody>
-      </p:sp>
-      <p:sp>
-        <p:nvSpPr>
-          <p:cNvPr id="11" name="Text 11"/>
-          <p:cNvSpPr txBox="1"/>
-          <p:nvPr/>
-        </p:nvSpPr>
-        <p:spPr>
-          <a:xfrm>
-            <a:off x="685800" y="5020056"/>
-            <a:ext cx="5760720" cy="411480"/>
-          </a:xfrm>
-          <a:prstGeom prst="rect">
-            <a:avLst/>
-          </a:prstGeom>
-          <a:noFill/>
-          <a:ln>
-            <a:noFill/>
-          </a:ln>
-        </p:spPr>
-        <p:txBody>
-          <a:bodyPr wrap="square" lIns="73152" tIns="73152" rIns="73152" bIns="73152" anchor="t">
-            <a:noAutofit/>
-          </a:bodyPr>
-          <a:lstStyle/>
-          <a:p>
-            <a:pPr algn="l">
-              <a:buNone/>
-            </a:pPr>
-            <a:r>
-              <a:rPr lang="en-US" sz="1800" b="1" i="0" dirty="0">
-                <a:solidFill>
-                  <a:srgbClr val="2DD4BF"/>
-                </a:solidFill>
-                <a:latin typeface="Montserrat"/>
-                <a:cs typeface="Montserrat"/>
-              </a:rPr>
-              <a:t>Reduced motion</a:t>
-            </a:r>
-            <a:endParaRPr lang="en-US" sz="1800" dirty="0"/>
-          </a:p>
-        </p:txBody>
-      </p:sp>
-      <p:sp>
-        <p:nvSpPr>
-          <p:cNvPr id="12" name="Text 12"/>
-          <p:cNvSpPr txBox="1"/>
-          <p:nvPr/>
-        </p:nvSpPr>
-        <p:spPr>
-          <a:xfrm>
-            <a:off x="685800" y="5404104"/>
-            <a:ext cx="5760720" cy="640080"/>
-          </a:xfrm>
-          <a:prstGeom prst="rect">
-            <a:avLst/>
-          </a:prstGeom>
-          <a:noFill/>
-          <a:ln>
-            <a:noFill/>
-          </a:ln>
-        </p:spPr>
-        <p:txBody>
-          <a:bodyPr wrap="square" lIns="73152" tIns="73152" rIns="73152" bIns="73152" anchor="t">
-            <a:noAutofit/>
-          </a:bodyPr>
-          <a:lstStyle/>
-          <a:p>
-            <a:pPr algn="l">
-              <a:buNone/>
-            </a:pPr>
-            <a:r>
-              <a:rPr lang="en-US" sz="1350" b="0" i="0" dirty="0">
-                <a:solidFill>
-                  <a:srgbClr val="E6EDF3"/>
-                </a:solidFill>
-                <a:latin typeface="Open Sans"/>
-                <a:cs typeface="Open Sans"/>
-              </a:rPr>
-              <a:t>Every animation switches off for people who turn off motion in their system settings.</a:t>
-            </a:r>
-            <a:endParaRPr lang="en-US" sz="1350" dirty="0"/>
-          </a:p>
-        </p:txBody>
-      </p:sp>
-      <p:pic>
-        <p:nvPicPr>
-          <p:cNvPr id="13" name="loader.png"/>
-          <p:cNvPicPr>
-            <a:picLocks noChangeAspect="1"/>
-          </p:cNvPicPr>
-          <p:nvPr/>
-        </p:nvPicPr>
-        <p:blipFill>
-          <a:blip r:embed="rId3"/>
-          <a:stretch>
-            <a:fillRect/>
-          </a:stretch>
-        </p:blipFill>
-        <p:spPr>
-          <a:xfrm>
-            <a:off x="6720840" y="1783080"/>
-            <a:ext cx="4800600" cy="3054927"/>
-          </a:xfrm>
-          <a:prstGeom prst="rect">
-            <a:avLst/>
-          </a:prstGeom>
-        </p:spPr>
-      </p:pic>
-      <p:sp>
-        <p:nvSpPr>
-          <p:cNvPr id="14" name="Text 14"/>
-          <p:cNvSpPr txBox="1"/>
-          <p:nvPr/>
-        </p:nvSpPr>
-        <p:spPr>
-          <a:xfrm>
-            <a:off x="6720840" y="4892040"/>
-            <a:ext cx="4800600" cy="822960"/>
-          </a:xfrm>
-          <a:prstGeom prst="rect">
-            <a:avLst/>
-          </a:prstGeom>
-          <a:noFill/>
-          <a:ln>
-            <a:noFill/>
-          </a:ln>
-        </p:spPr>
-        <p:txBody>
-          <a:bodyPr wrap="square" lIns="73152" tIns="73152" rIns="73152" bIns="73152" anchor="t">
-            <a:noAutofit/>
-          </a:bodyPr>
-          <a:lstStyle/>
-          <a:p>
-            <a:pPr algn="l">
-              <a:buNone/>
-            </a:pPr>
-            <a:r>
-              <a:rPr lang="en-US" sz="1200" b="0" i="1" dirty="0">
-                <a:solidFill>
-                  <a:srgbClr val="9FB3C8"/>
-                </a:solidFill>
-                <a:latin typeface="Open Sans"/>
-                <a:cs typeface="Open Sans"/>
-              </a:rPr>
-              <a:t>The loading screen does real work (it loads and scores the data) and passes the time with robotics jokes and fun facts.</a:t>
-            </a:r>
-            <a:endParaRPr lang="en-US" sz="1200" dirty="0"/>
-          </a:p>
-        </p:txBody>
-      </p:sp>
-      <p:sp>
-        <p:nvSpPr>
-          <p:cNvPr id="15" name="Shape 15"/>
+          <p:cNvPr id="5" name="Shape 5"/>
           <p:cNvSpPr/>
           <p:nvPr/>
         </p:nvSpPr>
         <p:spPr>
           <a:xfrm>
-            <a:off x="685800" y="6419088"/>
-            <a:ext cx="502920" cy="45720"/>
+            <a:off x="685800" y="2011680"/>
+            <a:ext cx="2560320" cy="2148840"/>
+          </a:xfrm>
+          <a:prstGeom prst="roundRect">
+            <a:avLst>
+              <a:gd name="adj" fmla="val 10000"/>
+            </a:avLst>
+          </a:prstGeom>
+          <a:solidFill>
+            <a:srgbClr val="151C26"/>
+          </a:solidFill>
+          <a:ln w="15875">
+            <a:solidFill>
+              <a:srgbClr val="23414A"/>
+            </a:solidFill>
+          </a:ln>
+        </p:spPr>
+        <p:txBody>
+          <a:bodyPr/>
+          <a:lstStyle/>
+          <a:p>
+            <a:endParaRPr lang="en-US"/>
+          </a:p>
+        </p:txBody>
+      </p:sp>
+      <p:sp>
+        <p:nvSpPr>
+          <p:cNvPr id="6" name="Shape 6"/>
+          <p:cNvSpPr/>
+          <p:nvPr/>
+        </p:nvSpPr>
+        <p:spPr>
+          <a:xfrm>
+            <a:off x="685800" y="2176272"/>
+            <a:ext cx="64008" cy="1819656"/>
           </a:xfrm>
           <a:prstGeom prst="rect">
             <a:avLst/>
@@ -4345,7 +4218,610 @@
       </p:sp>
       <p:sp>
         <p:nvSpPr>
+          <p:cNvPr id="7" name="Text 7"/>
+          <p:cNvSpPr txBox="1"/>
+          <p:nvPr/>
+        </p:nvSpPr>
+        <p:spPr>
+          <a:xfrm>
+            <a:off x="914400" y="2148840"/>
+            <a:ext cx="2194560" cy="457200"/>
+          </a:xfrm>
+          <a:prstGeom prst="rect">
+            <a:avLst/>
+          </a:prstGeom>
+          <a:noFill/>
+          <a:ln>
+            <a:noFill/>
+          </a:ln>
+        </p:spPr>
+        <p:txBody>
+          <a:bodyPr wrap="square" lIns="73152" tIns="73152" rIns="73152" bIns="73152" anchor="t">
+            <a:noAutofit/>
+          </a:bodyPr>
+          <a:lstStyle/>
+          <a:p>
+            <a:pPr algn="l">
+              <a:buNone/>
+            </a:pPr>
+            <a:r>
+              <a:rPr lang="en-US" sz="1700" b="1" i="0" dirty="0">
+                <a:solidFill>
+                  <a:srgbClr val="2DD4BF"/>
+                </a:solidFill>
+                <a:latin typeface="Montserrat"/>
+                <a:cs typeface="Montserrat"/>
+              </a:rPr>
+              <a:t>1  Integrity</a:t>
+            </a:r>
+            <a:endParaRPr lang="en-US" sz="1700" dirty="0"/>
+          </a:p>
+        </p:txBody>
+      </p:sp>
+      <p:sp>
+        <p:nvSpPr>
+          <p:cNvPr id="8" name="Text 8"/>
+          <p:cNvSpPr txBox="1"/>
+          <p:nvPr/>
+        </p:nvSpPr>
+        <p:spPr>
+          <a:xfrm>
+            <a:off x="914400" y="2578608"/>
+            <a:ext cx="2194560" cy="1463040"/>
+          </a:xfrm>
+          <a:prstGeom prst="rect">
+            <a:avLst/>
+          </a:prstGeom>
+          <a:noFill/>
+          <a:ln>
+            <a:noFill/>
+          </a:ln>
+        </p:spPr>
+        <p:txBody>
+          <a:bodyPr wrap="square" lIns="73152" tIns="73152" rIns="73152" bIns="73152" anchor="t">
+            <a:noAutofit/>
+          </a:bodyPr>
+          <a:lstStyle/>
+          <a:p>
+            <a:pPr algn="l">
+              <a:buNone/>
+            </a:pPr>
+            <a:r>
+              <a:rPr lang="en-US" sz="1300" b="0" i="0" dirty="0">
+                <a:solidFill>
+                  <a:srgbClr val="E6EDF3"/>
+                </a:solidFill>
+                <a:latin typeface="Open Sans"/>
+                <a:cs typeface="Open Sans"/>
+              </a:rPr>
+              <a:t>Is the timing steady? Any dropped frames, frozen channels or values out of range?</a:t>
+            </a:r>
+            <a:endParaRPr lang="en-US" sz="1300" dirty="0"/>
+          </a:p>
+        </p:txBody>
+      </p:sp>
+      <p:sp>
+        <p:nvSpPr>
+          <p:cNvPr id="9" name="Shape 9"/>
+          <p:cNvSpPr/>
+          <p:nvPr/>
+        </p:nvSpPr>
+        <p:spPr>
+          <a:xfrm>
+            <a:off x="3429000" y="2011680"/>
+            <a:ext cx="2560320" cy="2148840"/>
+          </a:xfrm>
+          <a:prstGeom prst="roundRect">
+            <a:avLst>
+              <a:gd name="adj" fmla="val 10000"/>
+            </a:avLst>
+          </a:prstGeom>
+          <a:solidFill>
+            <a:srgbClr val="151C26"/>
+          </a:solidFill>
+          <a:ln w="15875">
+            <a:solidFill>
+              <a:srgbClr val="23414A"/>
+            </a:solidFill>
+          </a:ln>
+        </p:spPr>
+        <p:txBody>
+          <a:bodyPr/>
+          <a:lstStyle/>
+          <a:p>
+            <a:endParaRPr lang="en-US"/>
+          </a:p>
+        </p:txBody>
+      </p:sp>
+      <p:sp>
+        <p:nvSpPr>
+          <p:cNvPr id="10" name="Shape 10"/>
+          <p:cNvSpPr/>
+          <p:nvPr/>
+        </p:nvSpPr>
+        <p:spPr>
+          <a:xfrm>
+            <a:off x="3429000" y="2176272"/>
+            <a:ext cx="64008" cy="1819656"/>
+          </a:xfrm>
+          <a:prstGeom prst="rect">
+            <a:avLst/>
+          </a:prstGeom>
+          <a:solidFill>
+            <a:srgbClr val="2DD4BF"/>
+          </a:solidFill>
+          <a:ln>
+            <a:noFill/>
+          </a:ln>
+        </p:spPr>
+        <p:txBody>
+          <a:bodyPr/>
+          <a:lstStyle/>
+          <a:p>
+            <a:endParaRPr lang="en-US"/>
+          </a:p>
+        </p:txBody>
+      </p:sp>
+      <p:sp>
+        <p:nvSpPr>
+          <p:cNvPr id="11" name="Text 11"/>
+          <p:cNvSpPr txBox="1"/>
+          <p:nvPr/>
+        </p:nvSpPr>
+        <p:spPr>
+          <a:xfrm>
+            <a:off x="3657600" y="2148840"/>
+            <a:ext cx="2194560" cy="457200"/>
+          </a:xfrm>
+          <a:prstGeom prst="rect">
+            <a:avLst/>
+          </a:prstGeom>
+          <a:noFill/>
+          <a:ln>
+            <a:noFill/>
+          </a:ln>
+        </p:spPr>
+        <p:txBody>
+          <a:bodyPr wrap="square" lIns="73152" tIns="73152" rIns="73152" bIns="73152" anchor="t">
+            <a:noAutofit/>
+          </a:bodyPr>
+          <a:lstStyle/>
+          <a:p>
+            <a:pPr algn="l">
+              <a:buNone/>
+            </a:pPr>
+            <a:r>
+              <a:rPr lang="en-US" sz="1700" b="1" i="0" dirty="0">
+                <a:solidFill>
+                  <a:srgbClr val="2DD4BF"/>
+                </a:solidFill>
+                <a:latin typeface="Montserrat"/>
+                <a:cs typeface="Montserrat"/>
+              </a:rPr>
+              <a:t>2  Labels</a:t>
+            </a:r>
+            <a:endParaRPr lang="en-US" sz="1700" dirty="0"/>
+          </a:p>
+        </p:txBody>
+      </p:sp>
+      <p:sp>
+        <p:nvSpPr>
+          <p:cNvPr id="12" name="Text 12"/>
+          <p:cNvSpPr txBox="1"/>
+          <p:nvPr/>
+        </p:nvSpPr>
+        <p:spPr>
+          <a:xfrm>
+            <a:off x="3657600" y="2578608"/>
+            <a:ext cx="2194560" cy="1463040"/>
+          </a:xfrm>
+          <a:prstGeom prst="rect">
+            <a:avLst/>
+          </a:prstGeom>
+          <a:noFill/>
+          <a:ln>
+            <a:noFill/>
+          </a:ln>
+        </p:spPr>
+        <p:txBody>
+          <a:bodyPr wrap="square" lIns="73152" tIns="73152" rIns="73152" bIns="73152" anchor="t">
+            <a:noAutofit/>
+          </a:bodyPr>
+          <a:lstStyle/>
+          <a:p>
+            <a:pPr algn="l">
+              <a:buNone/>
+            </a:pPr>
+            <a:r>
+              <a:rPr lang="en-US" sz="1300" b="0" i="0" dirty="0">
+                <a:solidFill>
+                  <a:srgbClr val="E6EDF3"/>
+                </a:solidFill>
+                <a:latin typeface="Open Sans"/>
+                <a:cs typeface="Open Sans"/>
+              </a:rPr>
+              <a:t>Was the robot told what it was doing? Missing or gibberish task text is flagged.</a:t>
+            </a:r>
+            <a:endParaRPr lang="en-US" sz="1300" dirty="0"/>
+          </a:p>
+        </p:txBody>
+      </p:sp>
+      <p:sp>
+        <p:nvSpPr>
+          <p:cNvPr id="13" name="Shape 13"/>
+          <p:cNvSpPr/>
+          <p:nvPr/>
+        </p:nvSpPr>
+        <p:spPr>
+          <a:xfrm>
+            <a:off x="6172200" y="2011680"/>
+            <a:ext cx="2560320" cy="2148840"/>
+          </a:xfrm>
+          <a:prstGeom prst="roundRect">
+            <a:avLst>
+              <a:gd name="adj" fmla="val 10000"/>
+            </a:avLst>
+          </a:prstGeom>
+          <a:solidFill>
+            <a:srgbClr val="151C26"/>
+          </a:solidFill>
+          <a:ln w="15875">
+            <a:solidFill>
+              <a:srgbClr val="23414A"/>
+            </a:solidFill>
+          </a:ln>
+        </p:spPr>
+        <p:txBody>
+          <a:bodyPr/>
+          <a:lstStyle/>
+          <a:p>
+            <a:endParaRPr lang="en-US"/>
+          </a:p>
+        </p:txBody>
+      </p:sp>
+      <p:sp>
+        <p:nvSpPr>
+          <p:cNvPr id="14" name="Shape 14"/>
+          <p:cNvSpPr/>
+          <p:nvPr/>
+        </p:nvSpPr>
+        <p:spPr>
+          <a:xfrm>
+            <a:off x="6172200" y="2176272"/>
+            <a:ext cx="64008" cy="1819656"/>
+          </a:xfrm>
+          <a:prstGeom prst="rect">
+            <a:avLst/>
+          </a:prstGeom>
+          <a:solidFill>
+            <a:srgbClr val="2DD4BF"/>
+          </a:solidFill>
+          <a:ln>
+            <a:noFill/>
+          </a:ln>
+        </p:spPr>
+        <p:txBody>
+          <a:bodyPr/>
+          <a:lstStyle/>
+          <a:p>
+            <a:endParaRPr lang="en-US"/>
+          </a:p>
+        </p:txBody>
+      </p:sp>
+      <p:sp>
+        <p:nvSpPr>
+          <p:cNvPr id="15" name="Text 15"/>
+          <p:cNvSpPr txBox="1"/>
+          <p:nvPr/>
+        </p:nvSpPr>
+        <p:spPr>
+          <a:xfrm>
+            <a:off x="6400800" y="2148840"/>
+            <a:ext cx="2194560" cy="457200"/>
+          </a:xfrm>
+          <a:prstGeom prst="rect">
+            <a:avLst/>
+          </a:prstGeom>
+          <a:noFill/>
+          <a:ln>
+            <a:noFill/>
+          </a:ln>
+        </p:spPr>
+        <p:txBody>
+          <a:bodyPr wrap="square" lIns="73152" tIns="73152" rIns="73152" bIns="73152" anchor="t">
+            <a:noAutofit/>
+          </a:bodyPr>
+          <a:lstStyle/>
+          <a:p>
+            <a:pPr algn="l">
+              <a:buNone/>
+            </a:pPr>
+            <a:r>
+              <a:rPr lang="en-US" sz="1700" b="1" i="0" dirty="0">
+                <a:solidFill>
+                  <a:srgbClr val="2DD4BF"/>
+                </a:solidFill>
+                <a:latin typeface="Montserrat"/>
+                <a:cs typeface="Montserrat"/>
+              </a:rPr>
+              <a:t>3  Unusualness</a:t>
+            </a:r>
+            <a:endParaRPr lang="en-US" sz="1700" dirty="0"/>
+          </a:p>
+        </p:txBody>
+      </p:sp>
+      <p:sp>
+        <p:nvSpPr>
           <p:cNvPr id="16" name="Text 16"/>
+          <p:cNvSpPr txBox="1"/>
+          <p:nvPr/>
+        </p:nvSpPr>
+        <p:spPr>
+          <a:xfrm>
+            <a:off x="6400800" y="2578608"/>
+            <a:ext cx="2194560" cy="1463040"/>
+          </a:xfrm>
+          <a:prstGeom prst="rect">
+            <a:avLst/>
+          </a:prstGeom>
+          <a:noFill/>
+          <a:ln>
+            <a:noFill/>
+          </a:ln>
+        </p:spPr>
+        <p:txBody>
+          <a:bodyPr wrap="square" lIns="73152" tIns="73152" rIns="73152" bIns="73152" anchor="t">
+            <a:noAutofit/>
+          </a:bodyPr>
+          <a:lstStyle/>
+          <a:p>
+            <a:pPr algn="l">
+              <a:buNone/>
+            </a:pPr>
+            <a:r>
+              <a:rPr lang="en-US" sz="1300" b="0" i="0" dirty="0">
+                <a:solidFill>
+                  <a:srgbClr val="E6EDF3"/>
+                </a:solidFill>
+                <a:latin typeface="Open Sans"/>
+                <a:cs typeface="Open Sans"/>
+              </a:rPr>
+              <a:t>How different is it from known-good recordings of the same task? A rank, not a probability.</a:t>
+            </a:r>
+            <a:endParaRPr lang="en-US" sz="1300" dirty="0"/>
+          </a:p>
+        </p:txBody>
+      </p:sp>
+      <p:sp>
+        <p:nvSpPr>
+          <p:cNvPr id="17" name="Shape 17"/>
+          <p:cNvSpPr/>
+          <p:nvPr/>
+        </p:nvSpPr>
+        <p:spPr>
+          <a:xfrm>
+            <a:off x="8915400" y="2011680"/>
+            <a:ext cx="2560320" cy="2148840"/>
+          </a:xfrm>
+          <a:prstGeom prst="roundRect">
+            <a:avLst>
+              <a:gd name="adj" fmla="val 10000"/>
+            </a:avLst>
+          </a:prstGeom>
+          <a:solidFill>
+            <a:srgbClr val="151C26"/>
+          </a:solidFill>
+          <a:ln w="15875">
+            <a:solidFill>
+              <a:srgbClr val="23414A"/>
+            </a:solidFill>
+          </a:ln>
+        </p:spPr>
+        <p:txBody>
+          <a:bodyPr/>
+          <a:lstStyle/>
+          <a:p>
+            <a:endParaRPr lang="en-US"/>
+          </a:p>
+        </p:txBody>
+      </p:sp>
+      <p:sp>
+        <p:nvSpPr>
+          <p:cNvPr id="18" name="Shape 18"/>
+          <p:cNvSpPr/>
+          <p:nvPr/>
+        </p:nvSpPr>
+        <p:spPr>
+          <a:xfrm>
+            <a:off x="8915400" y="2176272"/>
+            <a:ext cx="64008" cy="1819656"/>
+          </a:xfrm>
+          <a:prstGeom prst="rect">
+            <a:avLst/>
+          </a:prstGeom>
+          <a:solidFill>
+            <a:srgbClr val="2DD4BF"/>
+          </a:solidFill>
+          <a:ln>
+            <a:noFill/>
+          </a:ln>
+        </p:spPr>
+        <p:txBody>
+          <a:bodyPr/>
+          <a:lstStyle/>
+          <a:p>
+            <a:endParaRPr lang="en-US"/>
+          </a:p>
+        </p:txBody>
+      </p:sp>
+      <p:sp>
+        <p:nvSpPr>
+          <p:cNvPr id="19" name="Text 19"/>
+          <p:cNvSpPr txBox="1"/>
+          <p:nvPr/>
+        </p:nvSpPr>
+        <p:spPr>
+          <a:xfrm>
+            <a:off x="9144000" y="2148840"/>
+            <a:ext cx="2194560" cy="457200"/>
+          </a:xfrm>
+          <a:prstGeom prst="rect">
+            <a:avLst/>
+          </a:prstGeom>
+          <a:noFill/>
+          <a:ln>
+            <a:noFill/>
+          </a:ln>
+        </p:spPr>
+        <p:txBody>
+          <a:bodyPr wrap="square" lIns="73152" tIns="73152" rIns="73152" bIns="73152" anchor="t">
+            <a:noAutofit/>
+          </a:bodyPr>
+          <a:lstStyle/>
+          <a:p>
+            <a:pPr algn="l">
+              <a:buNone/>
+            </a:pPr>
+            <a:r>
+              <a:rPr lang="en-US" sz="1700" b="1" i="0" dirty="0">
+                <a:solidFill>
+                  <a:srgbClr val="2DD4BF"/>
+                </a:solidFill>
+                <a:latin typeface="Montserrat"/>
+                <a:cs typeface="Montserrat"/>
+              </a:rPr>
+              <a:t>4  Route + log</a:t>
+            </a:r>
+            <a:endParaRPr lang="en-US" sz="1700" dirty="0"/>
+          </a:p>
+        </p:txBody>
+      </p:sp>
+      <p:sp>
+        <p:nvSpPr>
+          <p:cNvPr id="20" name="Text 20"/>
+          <p:cNvSpPr txBox="1"/>
+          <p:nvPr/>
+        </p:nvSpPr>
+        <p:spPr>
+          <a:xfrm>
+            <a:off x="9144000" y="2578608"/>
+            <a:ext cx="2194560" cy="1463040"/>
+          </a:xfrm>
+          <a:prstGeom prst="rect">
+            <a:avLst/>
+          </a:prstGeom>
+          <a:noFill/>
+          <a:ln>
+            <a:noFill/>
+          </a:ln>
+        </p:spPr>
+        <p:txBody>
+          <a:bodyPr wrap="square" lIns="73152" tIns="73152" rIns="73152" bIns="73152" anchor="t">
+            <a:noAutofit/>
+          </a:bodyPr>
+          <a:lstStyle/>
+          <a:p>
+            <a:pPr algn="l">
+              <a:buNone/>
+            </a:pPr>
+            <a:r>
+              <a:rPr lang="en-US" sz="1300" b="0" i="0" dirty="0">
+                <a:solidFill>
+                  <a:srgbClr val="E6EDF3"/>
+                </a:solidFill>
+                <a:latin typeface="Open Sans"/>
+                <a:cs typeface="Open Sans"/>
+              </a:rPr>
+              <a:t>Accept, review or reject, and record why. History is never overwritten.</a:t>
+            </a:r>
+            <a:endParaRPr lang="en-US" sz="1300" dirty="0"/>
+          </a:p>
+        </p:txBody>
+      </p:sp>
+      <p:sp>
+        <p:nvSpPr>
+          <p:cNvPr id="21" name="Text 21"/>
+          <p:cNvSpPr txBox="1"/>
+          <p:nvPr/>
+        </p:nvSpPr>
+        <p:spPr>
+          <a:xfrm>
+            <a:off x="685800" y="4526280"/>
+            <a:ext cx="10789920" cy="822960"/>
+          </a:xfrm>
+          <a:prstGeom prst="rect">
+            <a:avLst/>
+          </a:prstGeom>
+          <a:noFill/>
+          <a:ln>
+            <a:noFill/>
+          </a:ln>
+        </p:spPr>
+        <p:txBody>
+          <a:bodyPr wrap="square" lIns="73152" tIns="73152" rIns="73152" bIns="73152" anchor="t">
+            <a:noAutofit/>
+          </a:bodyPr>
+          <a:lstStyle/>
+          <a:p>
+            <a:pPr algn="l">
+              <a:buNone/>
+            </a:pPr>
+            <a:r>
+              <a:rPr lang="en-US" sz="1500" b="1" i="0" dirty="0">
+                <a:solidFill>
+                  <a:srgbClr val="2DD4BF"/>
+                </a:solidFill>
+                <a:latin typeface="Open Sans"/>
+                <a:cs typeface="Open Sans"/>
+              </a:rPr>
+              <a:t>Works live too: </a:t>
+            </a:r>
+            <a:r>
+              <a:rPr lang="en-US" sz="1500" b="0" i="0" dirty="0">
+                <a:solidFill>
+                  <a:srgbClr val="E6EDF3"/>
+                </a:solidFill>
+                <a:latin typeface="Open Sans"/>
+                <a:cs typeface="Open Sans"/>
+              </a:rPr>
+              <a:t>a collector adapter streams frames from a running robot into the same gate, and per-robot profiles store each rig's expected rate and limits.</a:t>
+            </a:r>
+            <a:endParaRPr lang="en-US" sz="1500" dirty="0"/>
+          </a:p>
+        </p:txBody>
+      </p:sp>
+      <p:sp>
+        <p:nvSpPr>
+          <p:cNvPr id="22" name="Shape 22"/>
+          <p:cNvSpPr/>
+          <p:nvPr/>
+        </p:nvSpPr>
+        <p:spPr>
+          <a:xfrm>
+            <a:off x="685800" y="6419088"/>
+            <a:ext cx="502920" cy="45720"/>
+          </a:xfrm>
+          <a:prstGeom prst="rect">
+            <a:avLst/>
+          </a:prstGeom>
+          <a:solidFill>
+            <a:srgbClr val="2DD4BF"/>
+          </a:solidFill>
+          <a:ln>
+            <a:noFill/>
+          </a:ln>
+        </p:spPr>
+        <p:txBody>
+          <a:bodyPr/>
+          <a:lstStyle/>
+          <a:p>
+            <a:endParaRPr lang="en-US"/>
+          </a:p>
+        </p:txBody>
+      </p:sp>
+      <p:sp>
+        <p:nvSpPr>
+          <p:cNvPr id="23" name="Text 23"/>
           <p:cNvSpPr txBox="1"/>
           <p:nvPr/>
         </p:nvSpPr>
@@ -4387,7 +4863,7 @@
       </p:sp>
       <p:sp>
         <p:nvSpPr>
-          <p:cNvPr id="17" name="Text 17"/>
+          <p:cNvPr id="24" name="Text 24"/>
           <p:cNvSpPr txBox="1"/>
           <p:nvPr/>
         </p:nvSpPr>
@@ -4496,7 +4972,7 @@
                 <a:latin typeface="Montserrat"/>
                 <a:cs typeface="Montserrat"/>
               </a:rPr>
-              <a:t>IMPLEMENTATION</a:t>
+              <a:t>BUILT FOR EVERYONE</a:t>
             </a:r>
             <a:endParaRPr lang="en-US" sz="1300" dirty="0"/>
           </a:p>
@@ -4538,7 +5014,7 @@
                 <a:latin typeface="Montserrat"/>
                 <a:cs typeface="Montserrat"/>
               </a:rPr>
-              <a:t>How we used Kiro</a:t>
+              <a:t>Accessible, and fun to use</a:t>
             </a:r>
             <a:endParaRPr lang="en-US" sz="3400" dirty="0"/>
           </a:p>
@@ -4546,47 +5022,14 @@
       </p:sp>
       <p:sp>
         <p:nvSpPr>
-          <p:cNvPr id="5" name="Shape 5"/>
-          <p:cNvSpPr/>
+          <p:cNvPr id="5" name="Text 5"/>
+          <p:cNvSpPr txBox="1"/>
           <p:nvPr/>
         </p:nvSpPr>
         <p:spPr>
           <a:xfrm>
             <a:off x="685800" y="1783080"/>
-            <a:ext cx="5257800" cy="2011680"/>
-          </a:xfrm>
-          <a:prstGeom prst="roundRect">
-            <a:avLst>
-              <a:gd name="adj" fmla="val 10000"/>
-            </a:avLst>
-          </a:prstGeom>
-          <a:solidFill>
-            <a:srgbClr val="151C26"/>
-          </a:solidFill>
-          <a:ln w="15875">
-            <a:solidFill>
-              <a:srgbClr val="23414A"/>
-            </a:solidFill>
-          </a:ln>
-        </p:spPr>
-        <p:txBody>
-          <a:bodyPr/>
-          <a:lstStyle/>
-          <a:p>
-            <a:endParaRPr lang="en-US"/>
-          </a:p>
-        </p:txBody>
-      </p:sp>
-      <p:sp>
-        <p:nvSpPr>
-          <p:cNvPr id="6" name="Text 6"/>
-          <p:cNvSpPr txBox="1"/>
-          <p:nvPr/>
-        </p:nvSpPr>
-        <p:spPr>
-          <a:xfrm>
-            <a:off x="914400" y="1874520"/>
-            <a:ext cx="4846320" cy="457200"/>
+            <a:ext cx="5760720" cy="411480"/>
           </a:xfrm>
           <a:prstGeom prst="rect">
             <a:avLst/>
@@ -4613,7 +5056,7 @@
                 <a:latin typeface="Montserrat"/>
                 <a:cs typeface="Montserrat"/>
               </a:rPr>
-              <a:t>Kiro Crew  ·  local laptop</a:t>
+              <a:t>Narrated guided tour</a:t>
             </a:r>
             <a:endParaRPr lang="en-US" sz="1800" dirty="0"/>
           </a:p>
@@ -4621,35 +5064,31 @@
       </p:sp>
       <p:sp>
         <p:nvSpPr>
-          <p:cNvPr id="7" name="Text 7"/>
-          <p:cNvSpPr txBox="1"/>
-          <p:nvPr/>
-        </p:nvSpPr>
-        <p:spPr>
-          <a:xfrm>
-            <a:off x="914400" y="2331720"/>
-            <a:ext cx="4846320" cy="1737360"/>
-          </a:xfrm>
-          <a:prstGeom prst="rect">
-            <a:avLst/>
-          </a:prstGeom>
-          <a:noFill/>
-          <a:ln>
-            <a:noFill/>
-          </a:ln>
-        </p:spPr>
-        <p:txBody>
-          <a:bodyPr wrap="square" lIns="73152" tIns="73152" rIns="73152" bIns="73152" anchor="t">
-            <a:noAutofit/>
-          </a:bodyPr>
-          <a:lstStyle/>
-          <a:p>
-            <a:pPr algn="l" marL="285750" indent="-285750">
-              <a:buClr>
-                <a:srgbClr val="2DD4BF"/>
-              </a:buClr>
-              <a:buFont typeface="Arial"/>
-              <a:buChar char="•"/>
+          <p:cNvPr id="6" name="Text 6"/>
+          <p:cNvSpPr txBox="1"/>
+          <p:nvPr/>
+        </p:nvSpPr>
+        <p:spPr>
+          <a:xfrm>
+            <a:off x="685800" y="2167128"/>
+            <a:ext cx="5760720" cy="640080"/>
+          </a:xfrm>
+          <a:prstGeom prst="rect">
+            <a:avLst/>
+          </a:prstGeom>
+          <a:noFill/>
+          <a:ln>
+            <a:noFill/>
+          </a:ln>
+        </p:spPr>
+        <p:txBody>
+          <a:bodyPr wrap="square" lIns="73152" tIns="73152" rIns="73152" bIns="73152" anchor="t">
+            <a:noAutofit/>
+          </a:bodyPr>
+          <a:lstStyle/>
+          <a:p>
+            <a:pPr algn="l">
+              <a:buNone/>
             </a:pPr>
             <a:r>
               <a:rPr lang="en-US" sz="1350" b="0" i="0" dirty="0">
@@ -4659,20 +5098,81 @@
                 <a:latin typeface="Open Sans"/>
                 <a:cs typeface="Open Sans"/>
               </a:rPr>
-              <a:t>Set up Python and the virtual environment</a:t>
+              <a:t>11 steps. Voice, captions and a pointing arrow, so it works with or without sound.</a:t>
             </a:r>
             <a:endParaRPr lang="en-US" sz="1350" dirty="0"/>
           </a:p>
-          <a:p>
-            <a:pPr algn="l" marL="285750" indent="-285750">
-              <a:spcBef>
-                <a:spcPts val="400"/>
-              </a:spcBef>
-              <a:buClr>
-                <a:srgbClr val="2DD4BF"/>
-              </a:buClr>
-              <a:buFont typeface="Arial"/>
-              <a:buChar char="•"/>
+        </p:txBody>
+      </p:sp>
+      <p:sp>
+        <p:nvSpPr>
+          <p:cNvPr id="7" name="Text 7"/>
+          <p:cNvSpPr txBox="1"/>
+          <p:nvPr/>
+        </p:nvSpPr>
+        <p:spPr>
+          <a:xfrm>
+            <a:off x="685800" y="2862072"/>
+            <a:ext cx="5760720" cy="411480"/>
+          </a:xfrm>
+          <a:prstGeom prst="rect">
+            <a:avLst/>
+          </a:prstGeom>
+          <a:noFill/>
+          <a:ln>
+            <a:noFill/>
+          </a:ln>
+        </p:spPr>
+        <p:txBody>
+          <a:bodyPr wrap="square" lIns="73152" tIns="73152" rIns="73152" bIns="73152" anchor="t">
+            <a:noAutofit/>
+          </a:bodyPr>
+          <a:lstStyle/>
+          <a:p>
+            <a:pPr algn="l">
+              <a:buNone/>
+            </a:pPr>
+            <a:r>
+              <a:rPr lang="en-US" sz="1800" b="1" i="0" dirty="0">
+                <a:solidFill>
+                  <a:srgbClr val="2DD4BF"/>
+                </a:solidFill>
+                <a:latin typeface="Montserrat"/>
+                <a:cs typeface="Montserrat"/>
+              </a:rPr>
+              <a:t>Grounded help assistant</a:t>
+            </a:r>
+            <a:endParaRPr lang="en-US" sz="1800" dirty="0"/>
+          </a:p>
+        </p:txBody>
+      </p:sp>
+      <p:sp>
+        <p:nvSpPr>
+          <p:cNvPr id="8" name="Text 8"/>
+          <p:cNvSpPr txBox="1"/>
+          <p:nvPr/>
+        </p:nvSpPr>
+        <p:spPr>
+          <a:xfrm>
+            <a:off x="685800" y="3246120"/>
+            <a:ext cx="5760720" cy="640080"/>
+          </a:xfrm>
+          <a:prstGeom prst="rect">
+            <a:avLst/>
+          </a:prstGeom>
+          <a:noFill/>
+          <a:ln>
+            <a:noFill/>
+          </a:ln>
+        </p:spPr>
+        <p:txBody>
+          <a:bodyPr wrap="square" lIns="73152" tIns="73152" rIns="73152" bIns="73152" anchor="t">
+            <a:noAutofit/>
+          </a:bodyPr>
+          <a:lstStyle/>
+          <a:p>
+            <a:pPr algn="l">
+              <a:buNone/>
             </a:pPr>
             <a:r>
               <a:rPr lang="en-US" sz="1350" b="0" i="0" dirty="0">
@@ -4682,20 +5182,81 @@
                 <a:latin typeface="Open Sans"/>
                 <a:cs typeface="Open Sans"/>
               </a:rPr>
-              <a:t>Ran the app and the tests on the real machine</a:t>
+              <a:t>Answers only from DataMon's own docs, so it never invents an answer.</a:t>
             </a:r>
             <a:endParaRPr lang="en-US" sz="1350" dirty="0"/>
           </a:p>
-          <a:p>
-            <a:pPr algn="l" marL="285750" indent="-285750">
-              <a:spcBef>
-                <a:spcPts val="400"/>
-              </a:spcBef>
-              <a:buClr>
-                <a:srgbClr val="2DD4BF"/>
-              </a:buClr>
-              <a:buFont typeface="Arial"/>
-              <a:buChar char="•"/>
+        </p:txBody>
+      </p:sp>
+      <p:sp>
+        <p:nvSpPr>
+          <p:cNvPr id="9" name="Text 9"/>
+          <p:cNvSpPr txBox="1"/>
+          <p:nvPr/>
+        </p:nvSpPr>
+        <p:spPr>
+          <a:xfrm>
+            <a:off x="685800" y="3941064"/>
+            <a:ext cx="5760720" cy="411480"/>
+          </a:xfrm>
+          <a:prstGeom prst="rect">
+            <a:avLst/>
+          </a:prstGeom>
+          <a:noFill/>
+          <a:ln>
+            <a:noFill/>
+          </a:ln>
+        </p:spPr>
+        <p:txBody>
+          <a:bodyPr wrap="square" lIns="73152" tIns="73152" rIns="73152" bIns="73152" anchor="t">
+            <a:noAutofit/>
+          </a:bodyPr>
+          <a:lstStyle/>
+          <a:p>
+            <a:pPr algn="l">
+              <a:buNone/>
+            </a:pPr>
+            <a:r>
+              <a:rPr lang="en-US" sz="1800" b="1" i="0" dirty="0">
+                <a:solidFill>
+                  <a:srgbClr val="2DD4BF"/>
+                </a:solidFill>
+                <a:latin typeface="Montserrat"/>
+                <a:cs typeface="Montserrat"/>
+              </a:rPr>
+              <a:t>See it and hear it</a:t>
+            </a:r>
+            <a:endParaRPr lang="en-US" sz="1800" dirty="0"/>
+          </a:p>
+        </p:txBody>
+      </p:sp>
+      <p:sp>
+        <p:nvSpPr>
+          <p:cNvPr id="10" name="Text 10"/>
+          <p:cNvSpPr txBox="1"/>
+          <p:nvPr/>
+        </p:nvSpPr>
+        <p:spPr>
+          <a:xfrm>
+            <a:off x="685800" y="4325112"/>
+            <a:ext cx="5760720" cy="640080"/>
+          </a:xfrm>
+          <a:prstGeom prst="rect">
+            <a:avLst/>
+          </a:prstGeom>
+          <a:noFill/>
+          <a:ln>
+            <a:noFill/>
+          </a:ln>
+        </p:spPr>
+        <p:txBody>
+          <a:bodyPr wrap="square" lIns="73152" tIns="73152" rIns="73152" bIns="73152" anchor="t">
+            <a:noAutofit/>
+          </a:bodyPr>
+          <a:lstStyle/>
+          <a:p>
+            <a:pPr algn="l">
+              <a:buNone/>
             </a:pPr>
             <a:r>
               <a:rPr lang="en-US" sz="1350" b="0" i="0" dirty="0">
@@ -4705,7 +5266,7 @@
                 <a:latin typeface="Open Sans"/>
                 <a:cs typeface="Open Sans"/>
               </a:rPr>
-              <a:t>Shipped every feature as its own branch, pull request and merge</a:t>
+              <a:t>Rejections show a colour-coded verdict and play an alert sound.</a:t>
             </a:r>
             <a:endParaRPr lang="en-US" sz="1350" dirty="0"/>
           </a:p>
@@ -4713,47 +5274,14 @@
       </p:sp>
       <p:sp>
         <p:nvSpPr>
-          <p:cNvPr id="8" name="Shape 8"/>
-          <p:cNvSpPr/>
-          <p:nvPr/>
-        </p:nvSpPr>
-        <p:spPr>
-          <a:xfrm>
-            <a:off x="6263640" y="1783080"/>
-            <a:ext cx="5257800" cy="2011680"/>
-          </a:xfrm>
-          <a:prstGeom prst="roundRect">
-            <a:avLst>
-              <a:gd name="adj" fmla="val 10000"/>
-            </a:avLst>
-          </a:prstGeom>
-          <a:solidFill>
-            <a:srgbClr val="151C26"/>
-          </a:solidFill>
-          <a:ln w="15875">
-            <a:solidFill>
-              <a:srgbClr val="23414A"/>
-            </a:solidFill>
-          </a:ln>
-        </p:spPr>
-        <p:txBody>
-          <a:bodyPr/>
-          <a:lstStyle/>
-          <a:p>
-            <a:endParaRPr lang="en-US"/>
-          </a:p>
-        </p:txBody>
-      </p:sp>
-      <p:sp>
-        <p:nvSpPr>
-          <p:cNvPr id="9" name="Text 9"/>
-          <p:cNvSpPr txBox="1"/>
-          <p:nvPr/>
-        </p:nvSpPr>
-        <p:spPr>
-          <a:xfrm>
-            <a:off x="6492240" y="1874520"/>
-            <a:ext cx="4846320" cy="457200"/>
+          <p:cNvPr id="11" name="Text 11"/>
+          <p:cNvSpPr txBox="1"/>
+          <p:nvPr/>
+        </p:nvSpPr>
+        <p:spPr>
+          <a:xfrm>
+            <a:off x="685800" y="5020056"/>
+            <a:ext cx="5760720" cy="411480"/>
           </a:xfrm>
           <a:prstGeom prst="rect">
             <a:avLst/>
@@ -4780,7 +5308,7 @@
                 <a:latin typeface="Montserrat"/>
                 <a:cs typeface="Montserrat"/>
               </a:rPr>
-              <a:t>Kiro Web  ·  cloud sandbox</a:t>
+              <a:t>Reduced motion</a:t>
             </a:r>
             <a:endParaRPr lang="en-US" sz="1800" dirty="0"/>
           </a:p>
@@ -4788,35 +5316,31 @@
       </p:sp>
       <p:sp>
         <p:nvSpPr>
-          <p:cNvPr id="10" name="Text 10"/>
-          <p:cNvSpPr txBox="1"/>
-          <p:nvPr/>
-        </p:nvSpPr>
-        <p:spPr>
-          <a:xfrm>
-            <a:off x="6492240" y="2331720"/>
-            <a:ext cx="4846320" cy="1737360"/>
-          </a:xfrm>
-          <a:prstGeom prst="rect">
-            <a:avLst/>
-          </a:prstGeom>
-          <a:noFill/>
-          <a:ln>
-            <a:noFill/>
-          </a:ln>
-        </p:spPr>
-        <p:txBody>
-          <a:bodyPr wrap="square" lIns="73152" tIns="73152" rIns="73152" bIns="73152" anchor="t">
-            <a:noAutofit/>
-          </a:bodyPr>
-          <a:lstStyle/>
-          <a:p>
-            <a:pPr algn="l" marL="285750" indent="-285750">
-              <a:buClr>
-                <a:srgbClr val="2DD4BF"/>
-              </a:buClr>
-              <a:buFont typeface="Arial"/>
-              <a:buChar char="•"/>
+          <p:cNvPr id="12" name="Text 12"/>
+          <p:cNvSpPr txBox="1"/>
+          <p:nvPr/>
+        </p:nvSpPr>
+        <p:spPr>
+          <a:xfrm>
+            <a:off x="685800" y="5404104"/>
+            <a:ext cx="5760720" cy="640080"/>
+          </a:xfrm>
+          <a:prstGeom prst="rect">
+            <a:avLst/>
+          </a:prstGeom>
+          <a:noFill/>
+          <a:ln>
+            <a:noFill/>
+          </a:ln>
+        </p:spPr>
+        <p:txBody>
+          <a:bodyPr wrap="square" lIns="73152" tIns="73152" rIns="73152" bIns="73152" anchor="t">
+            <a:noAutofit/>
+          </a:bodyPr>
+          <a:lstStyle/>
+          <a:p>
+            <a:pPr algn="l">
+              <a:buNone/>
             </a:pPr>
             <a:r>
               <a:rPr lang="en-US" sz="1350" b="0" i="0" dirty="0">
@@ -4826,439 +5350,81 @@
                 <a:latin typeface="Open Sans"/>
                 <a:cs typeface="Open Sans"/>
               </a:rPr>
-              <a:t>No internet to install Streamlit, so it read the library's source on GitHub</a:t>
+              <a:t>Every animation switches off for people who turn off motion in their system settings.</a:t>
             </a:r>
             <a:endParaRPr lang="en-US" sz="1350" dirty="0"/>
           </a:p>
-          <a:p>
-            <a:pPr algn="l" marL="285750" indent="-285750">
-              <a:spcBef>
-                <a:spcPts val="400"/>
-              </a:spcBef>
-              <a:buClr>
-                <a:srgbClr val="2DD4BF"/>
-              </a:buClr>
-              <a:buFont typeface="Arial"/>
-              <a:buChar char="•"/>
-            </a:pPr>
-            <a:r>
-              <a:rPr lang="en-US" sz="1350" b="0" i="0" dirty="0">
-                <a:solidFill>
-                  <a:srgbClr val="E6EDF3"/>
+        </p:txBody>
+      </p:sp>
+      <p:pic>
+        <p:nvPicPr>
+          <p:cNvPr id="13" name="loader.png"/>
+          <p:cNvPicPr>
+            <a:picLocks noChangeAspect="1"/>
+          </p:cNvPicPr>
+          <p:nvPr/>
+        </p:nvPicPr>
+        <p:blipFill>
+          <a:blip r:embed="rId3"/>
+          <a:stretch>
+            <a:fillRect/>
+          </a:stretch>
+        </p:blipFill>
+        <p:spPr>
+          <a:xfrm>
+            <a:off x="6720840" y="1783080"/>
+            <a:ext cx="4800600" cy="3054927"/>
+          </a:xfrm>
+          <a:prstGeom prst="rect">
+            <a:avLst/>
+          </a:prstGeom>
+        </p:spPr>
+      </p:pic>
+      <p:sp>
+        <p:nvSpPr>
+          <p:cNvPr id="14" name="Text 14"/>
+          <p:cNvSpPr txBox="1"/>
+          <p:nvPr/>
+        </p:nvSpPr>
+        <p:spPr>
+          <a:xfrm>
+            <a:off x="6720840" y="4892040"/>
+            <a:ext cx="4800600" cy="822960"/>
+          </a:xfrm>
+          <a:prstGeom prst="rect">
+            <a:avLst/>
+          </a:prstGeom>
+          <a:noFill/>
+          <a:ln>
+            <a:noFill/>
+          </a:ln>
+        </p:spPr>
+        <p:txBody>
+          <a:bodyPr wrap="square" lIns="73152" tIns="73152" rIns="73152" bIns="73152" anchor="t">
+            <a:noAutofit/>
+          </a:bodyPr>
+          <a:lstStyle/>
+          <a:p>
+            <a:pPr algn="l">
+              <a:buNone/>
+            </a:pPr>
+            <a:r>
+              <a:rPr lang="en-US" sz="1200" b="0" i="1" dirty="0">
+                <a:solidFill>
+                  <a:srgbClr val="9FB3C8"/>
                 </a:solidFill>
                 <a:latin typeface="Open Sans"/>
                 <a:cs typeface="Open Sans"/>
               </a:rPr>
-              <a:t>Playwright power (MCP) rendered and screenshotted the UI</a:t>
-            </a:r>
-            <a:endParaRPr lang="en-US" sz="1350" dirty="0"/>
-          </a:p>
-          <a:p>
-            <a:pPr algn="l" marL="285750" indent="-285750">
-              <a:spcBef>
-                <a:spcPts val="400"/>
-              </a:spcBef>
-              <a:buClr>
-                <a:srgbClr val="2DD4BF"/>
-              </a:buClr>
-              <a:buFont typeface="Arial"/>
-              <a:buChar char="•"/>
-            </a:pPr>
-            <a:r>
-              <a:rPr lang="en-US" sz="1350" b="0" i="0" dirty="0">
-                <a:solidFill>
-                  <a:srgbClr val="E6EDF3"/>
-                </a:solidFill>
-                <a:latin typeface="Open Sans"/>
-                <a:cs typeface="Open Sans"/>
-              </a:rPr>
-              <a:t>GitHub CI ran the full test suite on every pull request</a:t>
-            </a:r>
-            <a:endParaRPr lang="en-US" sz="1350" dirty="0"/>
-          </a:p>
-        </p:txBody>
-      </p:sp>
-      <p:sp>
-        <p:nvSpPr>
-          <p:cNvPr id="11" name="Text 11"/>
-          <p:cNvSpPr txBox="1"/>
-          <p:nvPr/>
-        </p:nvSpPr>
-        <p:spPr>
-          <a:xfrm>
-            <a:off x="685800" y="4160520"/>
-            <a:ext cx="2560320" cy="548640"/>
-          </a:xfrm>
-          <a:prstGeom prst="rect">
-            <a:avLst/>
-          </a:prstGeom>
-          <a:noFill/>
-          <a:ln>
-            <a:noFill/>
-          </a:ln>
-        </p:spPr>
-        <p:txBody>
-          <a:bodyPr wrap="square" lIns="73152" tIns="73152" rIns="73152" bIns="73152" anchor="t">
-            <a:noAutofit/>
-          </a:bodyPr>
-          <a:lstStyle/>
-          <a:p>
-            <a:pPr algn="l">
-              <a:buNone/>
-            </a:pPr>
-            <a:r>
-              <a:rPr lang="en-US" sz="2800" b="1" i="0" dirty="0">
-                <a:solidFill>
-                  <a:srgbClr val="2DD4BF"/>
-                </a:solidFill>
-                <a:latin typeface="Montserrat"/>
-                <a:cs typeface="Montserrat"/>
-              </a:rPr>
-              <a:t>Specs</a:t>
-            </a:r>
-            <a:endParaRPr lang="en-US" sz="2800" dirty="0"/>
-          </a:p>
-        </p:txBody>
-      </p:sp>
-      <p:sp>
-        <p:nvSpPr>
-          <p:cNvPr id="12" name="Text 12"/>
-          <p:cNvSpPr txBox="1"/>
-          <p:nvPr/>
-        </p:nvSpPr>
-        <p:spPr>
-          <a:xfrm>
-            <a:off x="685800" y="4709160"/>
-            <a:ext cx="2560320" cy="731520"/>
-          </a:xfrm>
-          <a:prstGeom prst="rect">
-            <a:avLst/>
-          </a:prstGeom>
-          <a:noFill/>
-          <a:ln>
-            <a:noFill/>
-          </a:ln>
-        </p:spPr>
-        <p:txBody>
-          <a:bodyPr wrap="square" lIns="73152" tIns="73152" rIns="73152" bIns="73152" anchor="t">
-            <a:noAutofit/>
-          </a:bodyPr>
-          <a:lstStyle/>
-          <a:p>
-            <a:pPr algn="l">
-              <a:buNone/>
-            </a:pPr>
-            <a:r>
-              <a:rPr lang="en-US" sz="1300" b="0" i="0" dirty="0">
-                <a:solidFill>
-                  <a:srgbClr val="E6EDF3"/>
-                </a:solidFill>
-                <a:latin typeface="Open Sans"/>
-                <a:cs typeface="Open Sans"/>
-              </a:rPr>
-              <a:t>requirements, design and tasks for core features</a:t>
-            </a:r>
-            <a:endParaRPr lang="en-US" sz="1300" dirty="0"/>
-          </a:p>
-        </p:txBody>
-      </p:sp>
-      <p:sp>
-        <p:nvSpPr>
-          <p:cNvPr id="13" name="Text 13"/>
-          <p:cNvSpPr txBox="1"/>
-          <p:nvPr/>
-        </p:nvSpPr>
-        <p:spPr>
-          <a:xfrm>
-            <a:off x="3429000" y="4160520"/>
-            <a:ext cx="2560320" cy="548640"/>
-          </a:xfrm>
-          <a:prstGeom prst="rect">
-            <a:avLst/>
-          </a:prstGeom>
-          <a:noFill/>
-          <a:ln>
-            <a:noFill/>
-          </a:ln>
-        </p:spPr>
-        <p:txBody>
-          <a:bodyPr wrap="square" lIns="73152" tIns="73152" rIns="73152" bIns="73152" anchor="t">
-            <a:noAutofit/>
-          </a:bodyPr>
-          <a:lstStyle/>
-          <a:p>
-            <a:pPr algn="l">
-              <a:buNone/>
-            </a:pPr>
-            <a:r>
-              <a:rPr lang="en-US" sz="2800" b="1" i="0" dirty="0">
-                <a:solidFill>
-                  <a:srgbClr val="2DD4BF"/>
-                </a:solidFill>
-                <a:latin typeface="Montserrat"/>
-                <a:cs typeface="Montserrat"/>
-              </a:rPr>
-              <a:t>Steering</a:t>
-            </a:r>
-            <a:endParaRPr lang="en-US" sz="2800" dirty="0"/>
-          </a:p>
-        </p:txBody>
-      </p:sp>
-      <p:sp>
-        <p:nvSpPr>
-          <p:cNvPr id="14" name="Text 14"/>
-          <p:cNvSpPr txBox="1"/>
-          <p:nvPr/>
-        </p:nvSpPr>
-        <p:spPr>
-          <a:xfrm>
-            <a:off x="3429000" y="4709160"/>
-            <a:ext cx="2560320" cy="731520"/>
-          </a:xfrm>
-          <a:prstGeom prst="rect">
-            <a:avLst/>
-          </a:prstGeom>
-          <a:noFill/>
-          <a:ln>
-            <a:noFill/>
-          </a:ln>
-        </p:spPr>
-        <p:txBody>
-          <a:bodyPr wrap="square" lIns="73152" tIns="73152" rIns="73152" bIns="73152" anchor="t">
-            <a:noAutofit/>
-          </a:bodyPr>
-          <a:lstStyle/>
-          <a:p>
-            <a:pPr algn="l">
-              <a:buNone/>
-            </a:pPr>
-            <a:r>
-              <a:rPr lang="en-US" sz="1300" b="0" i="0" dirty="0">
-                <a:solidFill>
-                  <a:srgbClr val="E6EDF3"/>
-                </a:solidFill>
-                <a:latin typeface="Open Sans"/>
-                <a:cs typeface="Open Sans"/>
-              </a:rPr>
-              <a:t>2 docs: test before merge, no overclaiming</a:t>
-            </a:r>
-            <a:endParaRPr lang="en-US" sz="1300" dirty="0"/>
-          </a:p>
-        </p:txBody>
-      </p:sp>
-      <p:sp>
-        <p:nvSpPr>
-          <p:cNvPr id="15" name="Text 15"/>
-          <p:cNvSpPr txBox="1"/>
-          <p:nvPr/>
-        </p:nvSpPr>
-        <p:spPr>
-          <a:xfrm>
-            <a:off x="6172200" y="4160520"/>
-            <a:ext cx="2560320" cy="548640"/>
-          </a:xfrm>
-          <a:prstGeom prst="rect">
-            <a:avLst/>
-          </a:prstGeom>
-          <a:noFill/>
-          <a:ln>
-            <a:noFill/>
-          </a:ln>
-        </p:spPr>
-        <p:txBody>
-          <a:bodyPr wrap="square" lIns="73152" tIns="73152" rIns="73152" bIns="73152" anchor="t">
-            <a:noAutofit/>
-          </a:bodyPr>
-          <a:lstStyle/>
-          <a:p>
-            <a:pPr algn="l">
-              <a:buNone/>
-            </a:pPr>
-            <a:r>
-              <a:rPr lang="en-US" sz="2800" b="1" i="0" dirty="0">
-                <a:solidFill>
-                  <a:srgbClr val="2DD4BF"/>
-                </a:solidFill>
-                <a:latin typeface="Montserrat"/>
-                <a:cs typeface="Montserrat"/>
-              </a:rPr>
-              <a:t>21</a:t>
-            </a:r>
-            <a:endParaRPr lang="en-US" sz="2800" dirty="0"/>
-          </a:p>
-        </p:txBody>
-      </p:sp>
-      <p:sp>
-        <p:nvSpPr>
-          <p:cNvPr id="16" name="Text 16"/>
-          <p:cNvSpPr txBox="1"/>
-          <p:nvPr/>
-        </p:nvSpPr>
-        <p:spPr>
-          <a:xfrm>
-            <a:off x="6172200" y="4709160"/>
-            <a:ext cx="2560320" cy="731520"/>
-          </a:xfrm>
-          <a:prstGeom prst="rect">
-            <a:avLst/>
-          </a:prstGeom>
-          <a:noFill/>
-          <a:ln>
-            <a:noFill/>
-          </a:ln>
-        </p:spPr>
-        <p:txBody>
-          <a:bodyPr wrap="square" lIns="73152" tIns="73152" rIns="73152" bIns="73152" anchor="t">
-            <a:noAutofit/>
-          </a:bodyPr>
-          <a:lstStyle/>
-          <a:p>
-            <a:pPr algn="l">
-              <a:buNone/>
-            </a:pPr>
-            <a:r>
-              <a:rPr lang="en-US" sz="1300" b="0" i="0" dirty="0">
-                <a:solidFill>
-                  <a:srgbClr val="E6EDF3"/>
-                </a:solidFill>
-                <a:latin typeface="Open Sans"/>
-                <a:cs typeface="Open Sans"/>
-              </a:rPr>
-              <a:t>merged pull requests</a:t>
-            </a:r>
-            <a:endParaRPr lang="en-US" sz="1300" dirty="0"/>
-          </a:p>
-        </p:txBody>
-      </p:sp>
-      <p:sp>
-        <p:nvSpPr>
-          <p:cNvPr id="17" name="Text 17"/>
-          <p:cNvSpPr txBox="1"/>
-          <p:nvPr/>
-        </p:nvSpPr>
-        <p:spPr>
-          <a:xfrm>
-            <a:off x="8915400" y="4160520"/>
-            <a:ext cx="2560320" cy="548640"/>
-          </a:xfrm>
-          <a:prstGeom prst="rect">
-            <a:avLst/>
-          </a:prstGeom>
-          <a:noFill/>
-          <a:ln>
-            <a:noFill/>
-          </a:ln>
-        </p:spPr>
-        <p:txBody>
-          <a:bodyPr wrap="square" lIns="73152" tIns="73152" rIns="73152" bIns="73152" anchor="t">
-            <a:noAutofit/>
-          </a:bodyPr>
-          <a:lstStyle/>
-          <a:p>
-            <a:pPr algn="l">
-              <a:buNone/>
-            </a:pPr>
-            <a:r>
-              <a:rPr lang="en-US" sz="2800" b="1" i="0" dirty="0">
-                <a:solidFill>
-                  <a:srgbClr val="2DD4BF"/>
-                </a:solidFill>
-                <a:latin typeface="Montserrat"/>
-                <a:cs typeface="Montserrat"/>
-              </a:rPr>
-              <a:t>129</a:t>
-            </a:r>
-            <a:endParaRPr lang="en-US" sz="2800" dirty="0"/>
-          </a:p>
-        </p:txBody>
-      </p:sp>
-      <p:sp>
-        <p:nvSpPr>
-          <p:cNvPr id="18" name="Text 18"/>
-          <p:cNvSpPr txBox="1"/>
-          <p:nvPr/>
-        </p:nvSpPr>
-        <p:spPr>
-          <a:xfrm>
-            <a:off x="8915400" y="4709160"/>
-            <a:ext cx="2560320" cy="731520"/>
-          </a:xfrm>
-          <a:prstGeom prst="rect">
-            <a:avLst/>
-          </a:prstGeom>
-          <a:noFill/>
-          <a:ln>
-            <a:noFill/>
-          </a:ln>
-        </p:spPr>
-        <p:txBody>
-          <a:bodyPr wrap="square" lIns="73152" tIns="73152" rIns="73152" bIns="73152" anchor="t">
-            <a:noAutofit/>
-          </a:bodyPr>
-          <a:lstStyle/>
-          <a:p>
-            <a:pPr algn="l">
-              <a:buNone/>
-            </a:pPr>
-            <a:r>
-              <a:rPr lang="en-US" sz="1300" b="0" i="0" dirty="0">
-                <a:solidFill>
-                  <a:srgbClr val="E6EDF3"/>
-                </a:solidFill>
-                <a:latin typeface="Open Sans"/>
-                <a:cs typeface="Open Sans"/>
-              </a:rPr>
-              <a:t>tests passing on Python 3.9 &amp; 3.13</a:t>
-            </a:r>
-            <a:endParaRPr lang="en-US" sz="1300" dirty="0"/>
-          </a:p>
-        </p:txBody>
-      </p:sp>
-      <p:sp>
-        <p:nvSpPr>
-          <p:cNvPr id="19" name="Text 19"/>
-          <p:cNvSpPr txBox="1"/>
-          <p:nvPr/>
-        </p:nvSpPr>
-        <p:spPr>
-          <a:xfrm>
-            <a:off x="685800" y="5532120"/>
-            <a:ext cx="10789920" cy="457200"/>
-          </a:xfrm>
-          <a:prstGeom prst="rect">
-            <a:avLst/>
-          </a:prstGeom>
-          <a:noFill/>
-          <a:ln>
-            <a:noFill/>
-          </a:ln>
-        </p:spPr>
-        <p:txBody>
-          <a:bodyPr wrap="square" lIns="73152" tIns="73152" rIns="73152" bIns="73152" anchor="t">
-            <a:noAutofit/>
-          </a:bodyPr>
-          <a:lstStyle/>
-          <a:p>
-            <a:pPr algn="l">
-              <a:buNone/>
-            </a:pPr>
-            <a:r>
-              <a:rPr lang="en-US" sz="1250" b="0" i="1" dirty="0">
-                <a:solidFill>
-                  <a:srgbClr val="9FB3C8"/>
-                </a:solidFill>
-                <a:latin typeface="Open Sans"/>
-                <a:cs typeface="Open Sans"/>
-              </a:rPr>
-              <a:t>Full write-up and specs: the /.kiro folder in our repo.</a:t>
-            </a:r>
-            <a:endParaRPr lang="en-US" sz="1250" dirty="0"/>
-          </a:p>
-        </p:txBody>
-      </p:sp>
-      <p:sp>
-        <p:nvSpPr>
-          <p:cNvPr id="20" name="Shape 20"/>
+              <a:t>The loading screen does real work (it loads and scores the data) and passes the time with robotics jokes and fun facts.</a:t>
+            </a:r>
+            <a:endParaRPr lang="en-US" sz="1200" dirty="0"/>
+          </a:p>
+        </p:txBody>
+      </p:sp>
+      <p:sp>
+        <p:nvSpPr>
+          <p:cNvPr id="15" name="Shape 15"/>
           <p:cNvSpPr/>
           <p:nvPr/>
         </p:nvSpPr>
@@ -5287,7 +5453,7 @@
       </p:sp>
       <p:sp>
         <p:nvSpPr>
-          <p:cNvPr id="21" name="Text 21"/>
+          <p:cNvPr id="16" name="Text 16"/>
           <p:cNvSpPr txBox="1"/>
           <p:nvPr/>
         </p:nvSpPr>
@@ -5329,7 +5495,7 @@
       </p:sp>
       <p:sp>
         <p:nvSpPr>
-          <p:cNvPr id="22" name="Text 22"/>
+          <p:cNvPr id="17" name="Text 17"/>
           <p:cNvSpPr txBox="1"/>
           <p:nvPr/>
         </p:nvSpPr>
@@ -6204,69 +6370,87 @@
           <a:chExt cx="0" cy="0"/>
         </a:xfrm>
       </p:grpSpPr>
-      <p:pic>
-        <p:nvPicPr>
-          <p:cNvPr id="3" name="mascot.png"/>
-          <p:cNvPicPr>
-            <a:picLocks noChangeAspect="1"/>
-          </p:cNvPicPr>
-          <p:nvPr/>
-        </p:nvPicPr>
-        <p:blipFill>
-          <a:blip r:embed="rId3"/>
-          <a:stretch>
-            <a:fillRect/>
-          </a:stretch>
-        </p:blipFill>
-        <p:spPr>
-          <a:xfrm>
-            <a:off x="777240" y="914400"/>
-            <a:ext cx="1463040" cy="1463040"/>
-          </a:xfrm>
-          <a:prstGeom prst="rect">
-            <a:avLst/>
-          </a:prstGeom>
-        </p:spPr>
-      </p:pic>
-      <p:sp>
-        <p:nvSpPr>
-          <p:cNvPr id="4" name="Text 4"/>
-          <p:cNvSpPr txBox="1"/>
-          <p:nvPr/>
-        </p:nvSpPr>
-        <p:spPr>
-          <a:xfrm>
-            <a:off x="2468880" y="960120"/>
-            <a:ext cx="4572000" cy="914400"/>
-          </a:xfrm>
-          <a:prstGeom prst="rect">
-            <a:avLst/>
-          </a:prstGeom>
-          <a:noFill/>
-          <a:ln>
-            <a:noFill/>
-          </a:ln>
-        </p:spPr>
-        <p:txBody>
-          <a:bodyPr wrap="square" lIns="73152" tIns="73152" rIns="73152" bIns="73152" anchor="t">
-            <a:noAutofit/>
-          </a:bodyPr>
-          <a:lstStyle/>
-          <a:p>
-            <a:pPr algn="l">
-              <a:buNone/>
-            </a:pPr>
-            <a:r>
-              <a:rPr lang="en-US" sz="4000" b="1" i="0" dirty="0">
-                <a:solidFill>
-                  <a:srgbClr val="E6EDF3"/>
+      <p:sp>
+        <p:nvSpPr>
+          <p:cNvPr id="3" name="Text 3"/>
+          <p:cNvSpPr txBox="1"/>
+          <p:nvPr/>
+        </p:nvSpPr>
+        <p:spPr>
+          <a:xfrm>
+            <a:off x="685800" y="1463040"/>
+            <a:ext cx="10789920" cy="457200"/>
+          </a:xfrm>
+          <a:prstGeom prst="rect">
+            <a:avLst/>
+          </a:prstGeom>
+          <a:noFill/>
+          <a:ln>
+            <a:noFill/>
+          </a:ln>
+        </p:spPr>
+        <p:txBody>
+          <a:bodyPr wrap="square" lIns="73152" tIns="73152" rIns="73152" bIns="73152" anchor="t">
+            <a:noAutofit/>
+          </a:bodyPr>
+          <a:lstStyle/>
+          <a:p>
+            <a:pPr algn="ctr">
+              <a:buNone/>
+            </a:pPr>
+            <a:r>
+              <a:rPr lang="en-US" sz="1600" b="1" i="0" dirty="0">
+                <a:solidFill>
+                  <a:srgbClr val="2DD4BF"/>
                 </a:solidFill>
                 <a:latin typeface="Montserrat"/>
                 <a:cs typeface="Montserrat"/>
               </a:rPr>
-              <a:t>Try DataMon</a:t>
-            </a:r>
-            <a:endParaRPr lang="en-US" sz="4000" dirty="0"/>
+              <a:t>LIVE DEMO</a:t>
+            </a:r>
+            <a:endParaRPr lang="en-US" sz="1600" dirty="0"/>
+          </a:p>
+        </p:txBody>
+      </p:sp>
+      <p:sp>
+        <p:nvSpPr>
+          <p:cNvPr id="4" name="Text 4"/>
+          <p:cNvSpPr txBox="1"/>
+          <p:nvPr/>
+        </p:nvSpPr>
+        <p:spPr>
+          <a:xfrm>
+            <a:off x="685800" y="1920240"/>
+            <a:ext cx="10789920" cy="1097280"/>
+          </a:xfrm>
+          <a:prstGeom prst="rect">
+            <a:avLst/>
+          </a:prstGeom>
+          <a:noFill/>
+          <a:ln>
+            <a:noFill/>
+          </a:ln>
+        </p:spPr>
+        <p:txBody>
+          <a:bodyPr wrap="square" lIns="73152" tIns="73152" rIns="73152" bIns="73152" anchor="t">
+            <a:noAutofit/>
+          </a:bodyPr>
+          <a:lstStyle/>
+          <a:p>
+            <a:pPr algn="ctr">
+              <a:buNone/>
+            </a:pPr>
+            <a:r>
+              <a:rPr lang="en-US" sz="4800" b="1" i="0" dirty="0">
+                <a:solidFill>
+                  <a:srgbClr val="E6EDF3"/>
+                </a:solidFill>
+                <a:latin typeface="Montserrat"/>
+                <a:cs typeface="Montserrat"/>
+              </a:rPr>
+              <a:t>See it working</a:t>
+            </a:r>
+            <a:endParaRPr lang="en-US" sz="4800" dirty="0"/>
           </a:p>
         </p:txBody>
       </p:sp>
@@ -6278,50 +6462,8 @@
         </p:nvSpPr>
         <p:spPr>
           <a:xfrm>
-            <a:off x="2468880" y="1691640"/>
-            <a:ext cx="4572000" cy="548640"/>
-          </a:xfrm>
-          <a:prstGeom prst="rect">
-            <a:avLst/>
-          </a:prstGeom>
-          <a:noFill/>
-          <a:ln>
-            <a:noFill/>
-          </a:ln>
-        </p:spPr>
-        <p:txBody>
-          <a:bodyPr wrap="square" lIns="73152" tIns="73152" rIns="73152" bIns="73152" anchor="t">
-            <a:noAutofit/>
-          </a:bodyPr>
-          <a:lstStyle/>
-          <a:p>
-            <a:pPr algn="l">
-              <a:buNone/>
-            </a:pPr>
-            <a:r>
-              <a:rPr lang="en-US" sz="2000" b="0" i="1" dirty="0">
-                <a:solidFill>
-                  <a:srgbClr val="2DD4BF"/>
-                </a:solidFill>
-                <a:latin typeface="Open Sans"/>
-                <a:cs typeface="Open Sans"/>
-              </a:rPr>
-              <a:t>Good data in. Bad data out.</a:t>
-            </a:r>
-            <a:endParaRPr lang="en-US" sz="2000" dirty="0"/>
-          </a:p>
-        </p:txBody>
-      </p:sp>
-      <p:sp>
-        <p:nvSpPr>
-          <p:cNvPr id="6" name="Text 6"/>
-          <p:cNvSpPr txBox="1"/>
-          <p:nvPr/>
-        </p:nvSpPr>
-        <p:spPr>
-          <a:xfrm>
-            <a:off x="777240" y="2743200"/>
-            <a:ext cx="5760720" cy="2468880"/>
+            <a:off x="2651760" y="3291840"/>
+            <a:ext cx="6858000" cy="1463040"/>
           </a:xfrm>
           <a:prstGeom prst="roundRect">
             <a:avLst>
@@ -6338,35 +6480,16 @@
           </a:ln>
         </p:spPr>
         <p:txBody>
-          <a:bodyPr wrap="square" lIns="228600" tIns="228600" rIns="228600" bIns="228600" anchor="t">
-            <a:noAutofit/>
-          </a:bodyPr>
-          <a:lstStyle/>
-          <a:p>
-            <a:pPr algn="l">
-              <a:buNone/>
-            </a:pPr>
-            <a:r>
-              <a:rPr lang="en-US" sz="1200" b="1" i="0" dirty="0">
-                <a:solidFill>
-                  <a:srgbClr val="9FB3C8"/>
-                </a:solidFill>
-                <a:latin typeface="Montserrat"/>
-                <a:cs typeface="Montserrat"/>
-              </a:rPr>
-              <a:t>LIVE SITE</a:t>
-            </a:r>
-            <a:endParaRPr lang="en-US" sz="1200" dirty="0"/>
-          </a:p>
-          <a:p>
-            <a:pPr algn="l">
-              <a:spcBef>
-                <a:spcPts val="200"/>
-              </a:spcBef>
-              <a:buNone/>
-            </a:pPr>
-            <a:r>
-              <a:rPr lang="en-US" sz="1700" b="1" i="0" dirty="0">
+          <a:bodyPr wrap="square" lIns="73152" tIns="73152" rIns="73152" bIns="73152" anchor="ctr">
+            <a:noAutofit/>
+          </a:bodyPr>
+          <a:lstStyle/>
+          <a:p>
+            <a:pPr algn="ctr">
+              <a:buNone/>
+            </a:pPr>
+            <a:r>
+              <a:rPr lang="en-US" sz="2200" b="1" i="0" dirty="0">
                 <a:solidFill>
                   <a:srgbClr val="2DD4BF"/>
                 </a:solidFill>
@@ -6375,197 +6498,74 @@
               </a:rPr>
               <a:t>hackachusetts-datamon.streamlit.app</a:t>
             </a:r>
-            <a:endParaRPr lang="en-US" sz="1700" dirty="0"/>
-          </a:p>
-          <a:p>
-            <a:pPr algn="l">
+            <a:endParaRPr lang="en-US" sz="2200" dirty="0"/>
+          </a:p>
+          <a:p>
+            <a:pPr algn="ctr">
               <a:spcBef>
-                <a:spcPts val="1400"/>
+                <a:spcPts val="1000"/>
               </a:spcBef>
               <a:buNone/>
             </a:pPr>
             <a:r>
-              <a:rPr lang="en-US" sz="1200" b="1" i="0" dirty="0">
-                <a:solidFill>
-                  <a:srgbClr val="9FB3C8"/>
-                </a:solidFill>
-                <a:latin typeface="Montserrat"/>
-                <a:cs typeface="Montserrat"/>
-              </a:rPr>
-              <a:t>SIGN IN</a:t>
-            </a:r>
-            <a:endParaRPr lang="en-US" sz="1200" dirty="0"/>
-          </a:p>
-          <a:p>
-            <a:pPr algn="l">
-              <a:spcBef>
-                <a:spcPts val="200"/>
-              </a:spcBef>
-              <a:buNone/>
-            </a:pPr>
-            <a:r>
-              <a:rPr lang="en-US" sz="1700" b="1" i="0" dirty="0">
+              <a:rPr lang="en-US" sz="1800" b="0" i="0" dirty="0">
                 <a:solidFill>
                   <a:srgbClr val="E6EDF3"/>
                 </a:solidFill>
                 <a:latin typeface="Open Sans"/>
                 <a:cs typeface="Open Sans"/>
               </a:rPr>
-              <a:t>judge  /  Hello World!</a:t>
-            </a:r>
-            <a:endParaRPr lang="en-US" sz="1700" dirty="0"/>
-          </a:p>
-          <a:p>
-            <a:pPr algn="l">
-              <a:spcBef>
-                <a:spcPts val="1400"/>
-              </a:spcBef>
-              <a:buNone/>
-            </a:pPr>
-            <a:r>
-              <a:rPr lang="en-US" sz="1200" b="1" i="0" dirty="0">
+              <a:t>Sign in:  judge  /  Hello World!</a:t>
+            </a:r>
+            <a:endParaRPr lang="en-US" sz="1800" dirty="0"/>
+          </a:p>
+        </p:txBody>
+      </p:sp>
+      <p:sp>
+        <p:nvSpPr>
+          <p:cNvPr id="6" name="Text 6"/>
+          <p:cNvSpPr txBox="1"/>
+          <p:nvPr/>
+        </p:nvSpPr>
+        <p:spPr>
+          <a:xfrm>
+            <a:off x="685800" y="5120640"/>
+            <a:ext cx="10789920" cy="548640"/>
+          </a:xfrm>
+          <a:prstGeom prst="rect">
+            <a:avLst/>
+          </a:prstGeom>
+          <a:noFill/>
+          <a:ln>
+            <a:noFill/>
+          </a:ln>
+        </p:spPr>
+        <p:txBody>
+          <a:bodyPr wrap="square" lIns="73152" tIns="73152" rIns="73152" bIns="73152" anchor="t">
+            <a:noAutofit/>
+          </a:bodyPr>
+          <a:lstStyle/>
+          <a:p>
+            <a:pPr algn="ctr">
+              <a:buNone/>
+            </a:pPr>
+            <a:r>
+              <a:rPr lang="en-US" sz="1500" b="0" i="0" dirty="0">
                 <a:solidFill>
                   <a:srgbClr val="9FB3C8"/>
-                </a:solidFill>
-                <a:latin typeface="Montserrat"/>
-                <a:cs typeface="Montserrat"/>
-              </a:rPr>
-              <a:t>CODE + KIRO SPECS</a:t>
-            </a:r>
-            <a:endParaRPr lang="en-US" sz="1200" dirty="0"/>
-          </a:p>
-          <a:p>
-            <a:pPr algn="l">
-              <a:spcBef>
-                <a:spcPts val="200"/>
-              </a:spcBef>
-              <a:buNone/>
-            </a:pPr>
-            <a:r>
-              <a:rPr lang="en-US" sz="1700" b="1" i="0" dirty="0">
-                <a:solidFill>
-                  <a:srgbClr val="2DD4BF"/>
                 </a:solidFill>
                 <a:latin typeface="Open Sans"/>
                 <a:cs typeface="Open Sans"/>
               </a:rPr>
-              <a:t>github.com/AZALAH/HackachusettsR3</a:t>
-            </a:r>
-            <a:endParaRPr lang="en-US" sz="1700" dirty="0"/>
-          </a:p>
-        </p:txBody>
-      </p:sp>
-      <p:pic>
-        <p:nvPicPr>
-          <p:cNvPr id="7" name="login.png"/>
-          <p:cNvPicPr>
-            <a:picLocks noChangeAspect="1"/>
-          </p:cNvPicPr>
-          <p:nvPr/>
-        </p:nvPicPr>
-        <p:blipFill>
-          <a:blip r:embed="rId4"/>
-          <a:stretch>
-            <a:fillRect/>
-          </a:stretch>
-        </p:blipFill>
-        <p:spPr>
-          <a:xfrm>
-            <a:off x="6812280" y="960120"/>
-            <a:ext cx="4709160" cy="2996738"/>
-          </a:xfrm>
-          <a:prstGeom prst="rect">
-            <a:avLst/>
-          </a:prstGeom>
-        </p:spPr>
-      </p:pic>
-      <p:sp>
-        <p:nvSpPr>
-          <p:cNvPr id="8" name="Text 8"/>
-          <p:cNvSpPr txBox="1"/>
-          <p:nvPr/>
-        </p:nvSpPr>
-        <p:spPr>
-          <a:xfrm>
-            <a:off x="6812280" y="4069080"/>
-            <a:ext cx="4709160" cy="457200"/>
-          </a:xfrm>
-          <a:prstGeom prst="rect">
-            <a:avLst/>
-          </a:prstGeom>
-          <a:noFill/>
-          <a:ln>
-            <a:noFill/>
-          </a:ln>
-        </p:spPr>
-        <p:txBody>
-          <a:bodyPr wrap="square" lIns="73152" tIns="73152" rIns="73152" bIns="73152" anchor="t">
-            <a:noAutofit/>
-          </a:bodyPr>
-          <a:lstStyle/>
-          <a:p>
-            <a:pPr algn="ctr">
-              <a:buNone/>
-            </a:pPr>
-            <a:r>
-              <a:rPr lang="en-US" sz="1200" b="0" i="1" dirty="0">
-                <a:solidFill>
-                  <a:srgbClr val="9FB3C8"/>
-                </a:solidFill>
-                <a:latin typeface="Open Sans"/>
-                <a:cs typeface="Open Sans"/>
-              </a:rPr>
-              <a:t>The DataMon sign-in page</a:t>
-            </a:r>
-            <a:endParaRPr lang="en-US" sz="1200" dirty="0"/>
-          </a:p>
-        </p:txBody>
-      </p:sp>
-      <p:sp>
-        <p:nvSpPr>
-          <p:cNvPr id="9" name="Text 9"/>
-          <p:cNvSpPr txBox="1"/>
-          <p:nvPr/>
-        </p:nvSpPr>
-        <p:spPr>
-          <a:xfrm>
-            <a:off x="6812280" y="4846320"/>
-            <a:ext cx="4709160" cy="822960"/>
-          </a:xfrm>
-          <a:prstGeom prst="rect">
-            <a:avLst/>
-          </a:prstGeom>
-          <a:noFill/>
-          <a:ln>
-            <a:noFill/>
-          </a:ln>
-        </p:spPr>
-        <p:txBody>
-          <a:bodyPr wrap="square" lIns="73152" tIns="73152" rIns="73152" bIns="73152" anchor="t">
-            <a:noAutofit/>
-          </a:bodyPr>
-          <a:lstStyle/>
-          <a:p>
-            <a:pPr algn="ctr">
-              <a:buNone/>
-            </a:pPr>
-            <a:r>
-              <a:rPr lang="en-US" sz="3000" b="1" i="0" dirty="0">
-                <a:solidFill>
-                  <a:srgbClr val="E6EDF3"/>
-                </a:solidFill>
-                <a:latin typeface="Montserrat"/>
-                <a:cs typeface="Montserrat"/>
-              </a:rPr>
-              <a:t>Thank you!</a:t>
-            </a:r>
-            <a:endParaRPr lang="en-US" sz="3000" dirty="0"/>
-          </a:p>
-        </p:txBody>
-      </p:sp>
-      <p:sp>
-        <p:nvSpPr>
-          <p:cNvPr id="10" name="Shape 10"/>
+              <a:t>Real public data: 100 DROID recordings and a BridgeData V2 sample, in the open LeRobot format.</a:t>
+            </a:r>
+            <a:endParaRPr lang="en-US" sz="1500" dirty="0"/>
+          </a:p>
+        </p:txBody>
+      </p:sp>
+      <p:sp>
+        <p:nvSpPr>
+          <p:cNvPr id="7" name="Shape 7"/>
           <p:cNvSpPr/>
           <p:nvPr/>
         </p:nvSpPr>
@@ -6594,7 +6594,7 @@
       </p:sp>
       <p:sp>
         <p:nvSpPr>
-          <p:cNvPr id="11" name="Text 11"/>
+          <p:cNvPr id="8" name="Text 8"/>
           <p:cNvSpPr txBox="1"/>
           <p:nvPr/>
         </p:nvSpPr>
@@ -6636,7 +6636,7 @@
       </p:sp>
       <p:sp>
         <p:nvSpPr>
-          <p:cNvPr id="12" name="Text 12"/>
+          <p:cNvPr id="9" name="Text 9"/>
           <p:cNvSpPr txBox="1"/>
           <p:nvPr/>
         </p:nvSpPr>

</xml_diff>

<commit_message>
Credit ElevenLabs for the guided-tour narration
Added to the README, narration folder, submission text, video script
(spoken line, on-screen caption, video description), and the deck.
</commit_message>
<xml_diff>
--- a/presentation/DataMon.pptx
+++ b/presentation/DataMon.pptx
@@ -3926,7 +3926,49 @@
       </p:sp>
       <p:sp>
         <p:nvSpPr>
-          <p:cNvPr id="10" name="Shape 10"/>
+          <p:cNvPr id="10" name="Text 10"/>
+          <p:cNvSpPr txBox="1"/>
+          <p:nvPr/>
+        </p:nvSpPr>
+        <p:spPr>
+          <a:xfrm>
+            <a:off x="777240" y="5760720"/>
+            <a:ext cx="10058400" cy="365760"/>
+          </a:xfrm>
+          <a:prstGeom prst="rect">
+            <a:avLst/>
+          </a:prstGeom>
+          <a:noFill/>
+          <a:ln>
+            <a:noFill/>
+          </a:ln>
+        </p:spPr>
+        <p:txBody>
+          <a:bodyPr wrap="square" lIns="73152" tIns="73152" rIns="73152" bIns="73152" anchor="t">
+            <a:noAutofit/>
+          </a:bodyPr>
+          <a:lstStyle/>
+          <a:p>
+            <a:pPr algn="l">
+              <a:buNone/>
+            </a:pPr>
+            <a:r>
+              <a:rPr lang="en-US" sz="1100" b="0" i="1" dirty="0">
+                <a:solidFill>
+                  <a:srgbClr val="9FB3C8"/>
+                </a:solidFill>
+                <a:latin typeface="Open Sans"/>
+                <a:cs typeface="Open Sans"/>
+              </a:rPr>
+              <a:t>Guided-tour narration voiced with ElevenLabs text-to-speech.</a:t>
+            </a:r>
+            <a:endParaRPr lang="en-US" sz="1100" dirty="0"/>
+          </a:p>
+        </p:txBody>
+      </p:sp>
+      <p:sp>
+        <p:nvSpPr>
+          <p:cNvPr id="11" name="Shape 11"/>
           <p:cNvSpPr/>
           <p:nvPr/>
         </p:nvSpPr>
@@ -3955,7 +3997,7 @@
       </p:sp>
       <p:sp>
         <p:nvSpPr>
-          <p:cNvPr id="11" name="Text 11"/>
+          <p:cNvPr id="12" name="Text 12"/>
           <p:cNvSpPr txBox="1"/>
           <p:nvPr/>
         </p:nvSpPr>
@@ -3997,7 +4039,7 @@
       </p:sp>
       <p:sp>
         <p:nvSpPr>
-          <p:cNvPr id="12" name="Text 12"/>
+          <p:cNvPr id="13" name="Text 13"/>
           <p:cNvSpPr txBox="1"/>
           <p:nvPr/>
         </p:nvSpPr>
@@ -5098,7 +5140,7 @@
                 <a:latin typeface="Open Sans"/>
                 <a:cs typeface="Open Sans"/>
               </a:rPr>
-              <a:t>11 steps. Voice, captions and a pointing arrow, so it works with or without sound.</a:t>
+              <a:t>11 steps. Voice (ElevenLabs), captions and a pointing arrow, so it works with or without sound.</a:t>
             </a:r>
             <a:endParaRPr lang="en-US" sz="1350" dirty="0"/>
           </a:p>

</xml_diff>